<commit_message>
Fix PPTX: proper Snowflake logo (transparent PNG), light bg on content slides
Previous version had broken logo (opaque white square from bad SVG conversion).
Now uses properly extracted Snowflake snowflake icon with transparency plus
text-rendered wordmark. Light background on content slides, dark on title/reveal.

.... Generated with [Cortex Code](https://docs.snowflake.com/en/user-guide/cortex-code/cortex-code)

Co-Authored-By: Cortex Code <noreply@snowflake.com>
</commit_message>
<xml_diff>
--- a/docs/First_Solar_Demo_Narrative.pptx
+++ b/docs/First_Solar_Demo_Narrative.pptx
@@ -3095,7 +3095,7 @@
     <p:bg>
       <p:bgPr>
         <a:solidFill>
-          <a:srgbClr val="05142B"/>
+          <a:srgbClr val="11273F"/>
         </a:solidFill>
         <a:effectLst/>
       </p:bgPr>
@@ -3109,7 +3109,7 @@
       <p:grpSpPr/>
       <p:pic>
         <p:nvPicPr>
-          <p:cNvPr id="2" name="Picture 1" descr="snowflake_logo_white.png"/>
+          <p:cNvPr id="2" name="Picture 1" descr="sf_logo_combined.png"/>
           <p:cNvPicPr>
             <a:picLocks noChangeAspect="1"/>
           </p:cNvPicPr>
@@ -3123,8 +3123,8 @@
         </p:blipFill>
         <p:spPr>
           <a:xfrm>
-            <a:off x="457200" y="274320"/>
-            <a:ext cx="457200" cy="457200"/>
+            <a:off x="365760" y="228600"/>
+            <a:ext cx="2468880" cy="411480"/>
           </a:xfrm>
           <a:prstGeom prst="rect">
             <a:avLst/>
@@ -3139,8 +3139,8 @@
         </p:nvSpPr>
         <p:spPr>
           <a:xfrm>
-            <a:off x="457200" y="6446520"/>
-            <a:ext cx="11247120" cy="27432"/>
+            <a:off x="0" y="6583680"/>
+            <a:ext cx="12191695" cy="36576"/>
           </a:xfrm>
           <a:prstGeom prst="rect">
             <a:avLst/>
@@ -3176,22 +3176,22 @@
       </p:sp>
       <p:pic>
         <p:nvPicPr>
-          <p:cNvPr id="4" name="Picture 3" descr="snowflake_logo_white.png"/>
+          <p:cNvPr id="4" name="Picture 3" descr="sf_icon_400.png"/>
           <p:cNvPicPr>
             <a:picLocks noChangeAspect="1"/>
           </p:cNvPicPr>
           <p:nvPr/>
         </p:nvPicPr>
         <p:blipFill>
-          <a:blip r:embed="rId2"/>
+          <a:blip r:embed="rId3"/>
           <a:stretch>
             <a:fillRect/>
           </a:stretch>
         </p:blipFill>
         <p:spPr>
           <a:xfrm>
-            <a:off x="7772400" y="1371600"/>
-            <a:ext cx="4114800" cy="4114800"/>
+            <a:off x="8229600" y="1097280"/>
+            <a:ext cx="7734132" cy="4389120"/>
           </a:xfrm>
           <a:prstGeom prst="rect">
             <a:avLst/>
@@ -3241,7 +3241,7 @@
         </p:nvSpPr>
         <p:spPr>
           <a:xfrm>
-            <a:off x="731520" y="2560320"/>
+            <a:off x="731520" y="2651760"/>
             <a:ext cx="6400800" cy="914400"/>
           </a:xfrm>
           <a:prstGeom prst="rect">
@@ -3256,7 +3256,7 @@
           <a:lstStyle/>
           <a:p>
             <a:pPr algn="l">
-              <a:defRPr sz="3200" b="1">
+              <a:defRPr sz="3000" b="1">
                 <a:solidFill>
                   <a:srgbClr val="29B5E8"/>
                 </a:solidFill>
@@ -3276,8 +3276,8 @@
         </p:nvSpPr>
         <p:spPr>
           <a:xfrm>
-            <a:off x="731520" y="3474720"/>
-            <a:ext cx="6400800" cy="731520"/>
+            <a:off x="731520" y="3566160"/>
+            <a:ext cx="6400800" cy="548640"/>
           </a:xfrm>
           <a:prstGeom prst="rect">
             <a:avLst/>
@@ -3291,9 +3291,9 @@
           <a:lstStyle/>
           <a:p>
             <a:pPr algn="l">
-              <a:defRPr sz="1800" b="0">
-                <a:solidFill>
-                  <a:srgbClr val="8E9EAB"/>
+              <a:defRPr sz="1700" b="0">
+                <a:solidFill>
+                  <a:srgbClr val="6B7B8D"/>
                 </a:solidFill>
               </a:defRPr>
             </a:pPr>
@@ -3311,7 +3311,7 @@
         </p:nvSpPr>
         <p:spPr>
           <a:xfrm>
-            <a:off x="731520" y="4206240"/>
+            <a:off x="731520" y="4114800"/>
             <a:ext cx="6400800" cy="457200"/>
           </a:xfrm>
           <a:prstGeom prst="rect">
@@ -3326,9 +3326,9 @@
           <a:lstStyle/>
           <a:p>
             <a:pPr algn="l">
-              <a:defRPr sz="1600" b="0">
-                <a:solidFill>
-                  <a:srgbClr val="8E9EAB"/>
+              <a:defRPr sz="1500" b="0">
+                <a:solidFill>
+                  <a:srgbClr val="6B7B8D"/>
                 </a:solidFill>
               </a:defRPr>
             </a:pPr>
@@ -3347,18 +3347,16 @@
         <p:spPr>
           <a:xfrm>
             <a:off x="731520" y="5303520"/>
-            <a:ext cx="3200400" cy="822960"/>
+            <a:ext cx="3200400" cy="731520"/>
           </a:xfrm>
           <a:prstGeom prst="roundRect">
             <a:avLst/>
           </a:prstGeom>
           <a:solidFill>
-            <a:srgbClr val="11273F"/>
+            <a:srgbClr val="29B5E8"/>
           </a:solidFill>
-          <a:ln w="25400">
-            <a:solidFill>
-              <a:srgbClr val="29B5E8"/>
-            </a:solidFill>
+          <a:ln>
+            <a:noFill/>
           </a:ln>
         </p:spPr>
         <p:style>
@@ -3401,18 +3399,16 @@
         <p:spPr>
           <a:xfrm>
             <a:off x="4206240" y="5303520"/>
-            <a:ext cx="3200400" cy="822960"/>
+            <a:ext cx="3200400" cy="731520"/>
           </a:xfrm>
           <a:prstGeom prst="roundRect">
             <a:avLst/>
           </a:prstGeom>
           <a:solidFill>
-            <a:srgbClr val="11273F"/>
+            <a:srgbClr val="29B5E8"/>
           </a:solidFill>
-          <a:ln w="25400">
-            <a:solidFill>
-              <a:srgbClr val="29B5E8"/>
-            </a:solidFill>
+          <a:ln>
+            <a:noFill/>
           </a:ln>
         </p:spPr>
         <p:style>
@@ -3455,18 +3451,16 @@
         <p:spPr>
           <a:xfrm>
             <a:off x="7680960" y="5303520"/>
-            <a:ext cx="3200400" cy="822960"/>
+            <a:ext cx="3200400" cy="731520"/>
           </a:xfrm>
           <a:prstGeom prst="roundRect">
             <a:avLst/>
           </a:prstGeom>
           <a:solidFill>
-            <a:srgbClr val="11273F"/>
+            <a:srgbClr val="29B5E8"/>
           </a:solidFill>
-          <a:ln w="25400">
-            <a:solidFill>
-              <a:srgbClr val="29B5E8"/>
-            </a:solidFill>
+          <a:ln>
+            <a:noFill/>
           </a:ln>
         </p:spPr>
         <p:style>
@@ -3514,7 +3508,7 @@
     <p:bg>
       <p:bgPr>
         <a:solidFill>
-          <a:srgbClr val="05142B"/>
+          <a:srgbClr val="F8FAFC"/>
         </a:solidFill>
         <a:effectLst/>
       </p:bgPr>
@@ -3528,7 +3522,7 @@
       <p:grpSpPr/>
       <p:pic>
         <p:nvPicPr>
-          <p:cNvPr id="2" name="Picture 1" descr="snowflake_logo_white.png"/>
+          <p:cNvPr id="2" name="Picture 1" descr="sf_logo_combined.png"/>
           <p:cNvPicPr>
             <a:picLocks noChangeAspect="1"/>
           </p:cNvPicPr>
@@ -3542,8 +3536,8 @@
         </p:blipFill>
         <p:spPr>
           <a:xfrm>
-            <a:off x="457200" y="274320"/>
-            <a:ext cx="457200" cy="457200"/>
+            <a:off x="365760" y="228600"/>
+            <a:ext cx="2468880" cy="411480"/>
           </a:xfrm>
           <a:prstGeom prst="rect">
             <a:avLst/>
@@ -3558,8 +3552,8 @@
         </p:nvSpPr>
         <p:spPr>
           <a:xfrm>
-            <a:off x="457200" y="6446520"/>
-            <a:ext cx="11247120" cy="27432"/>
+            <a:off x="0" y="6583680"/>
+            <a:ext cx="12191695" cy="36576"/>
           </a:xfrm>
           <a:prstGeom prst="rect">
             <a:avLst/>
@@ -3601,7 +3595,7 @@
         </p:nvSpPr>
         <p:spPr>
           <a:xfrm>
-            <a:off x="731520" y="731520"/>
+            <a:off x="731520" y="777240"/>
             <a:ext cx="10058400" cy="548640"/>
           </a:xfrm>
           <a:prstGeom prst="rect">
@@ -3616,14 +3610,14 @@
           <a:lstStyle/>
           <a:p>
             <a:pPr algn="l">
-              <a:defRPr sz="3200" b="1">
-                <a:solidFill>
-                  <a:srgbClr val="29B5E8"/>
-                </a:solidFill>
-              </a:defRPr>
-            </a:pPr>
-            <a:r>
-              <a:t>Demo Flow</a:t>
+              <a:defRPr sz="3000" b="1">
+                <a:solidFill>
+                  <a:srgbClr val="11273F"/>
+                </a:solidFill>
+              </a:defRPr>
+            </a:pPr>
+            <a:r>
+              <a:t>Demo Flow — The Arc</a:t>
             </a:r>
           </a:p>
         </p:txBody>
@@ -3637,7 +3631,7 @@
         <p:spPr>
           <a:xfrm>
             <a:off x="457200" y="1645920"/>
-            <a:ext cx="2560320" cy="1828800"/>
+            <a:ext cx="2560320" cy="1645920"/>
           </a:xfrm>
           <a:prstGeom prst="roundRect">
             <a:avLst/>
@@ -3668,7 +3662,7 @@
           <a:lstStyle/>
           <a:p>
             <a:pPr algn="ctr">
-              <a:defRPr sz="1400" b="1">
+              <a:defRPr sz="1300" b="1">
                 <a:solidFill>
                   <a:srgbClr val="FFFFFF"/>
                 </a:solidFill>
@@ -3696,7 +3690,7 @@
         </p:nvSpPr>
         <p:spPr>
           <a:xfrm>
-            <a:off x="3063240" y="2377440"/>
+            <a:off x="3063240" y="2286000"/>
             <a:ext cx="274320" cy="274320"/>
           </a:xfrm>
           <a:prstGeom prst="rightArrow">
@@ -3740,7 +3734,7 @@
         <p:spPr>
           <a:xfrm>
             <a:off x="3383280" y="1645920"/>
-            <a:ext cx="2560320" cy="1828800"/>
+            <a:ext cx="2560320" cy="1645920"/>
           </a:xfrm>
           <a:prstGeom prst="roundRect">
             <a:avLst/>
@@ -3771,7 +3765,7 @@
           <a:lstStyle/>
           <a:p>
             <a:pPr algn="ctr">
-              <a:defRPr sz="1400" b="1">
+              <a:defRPr sz="1300" b="1">
                 <a:solidFill>
                   <a:srgbClr val="FFFFFF"/>
                 </a:solidFill>
@@ -3799,7 +3793,7 @@
         </p:nvSpPr>
         <p:spPr>
           <a:xfrm>
-            <a:off x="5989320" y="2377440"/>
+            <a:off x="5989320" y="2286000"/>
             <a:ext cx="274320" cy="274320"/>
           </a:xfrm>
           <a:prstGeom prst="rightArrow">
@@ -3843,7 +3837,7 @@
         <p:spPr>
           <a:xfrm>
             <a:off x="6309360" y="1645920"/>
-            <a:ext cx="2560320" cy="1828800"/>
+            <a:ext cx="2560320" cy="1645920"/>
           </a:xfrm>
           <a:prstGeom prst="roundRect">
             <a:avLst/>
@@ -3874,7 +3868,7 @@
           <a:lstStyle/>
           <a:p>
             <a:pPr algn="ctr">
-              <a:defRPr sz="1400" b="1">
+              <a:defRPr sz="1300" b="1">
                 <a:solidFill>
                   <a:srgbClr val="FFFFFF"/>
                 </a:solidFill>
@@ -3902,7 +3896,7 @@
         </p:nvSpPr>
         <p:spPr>
           <a:xfrm>
-            <a:off x="8915400" y="2377440"/>
+            <a:off x="8915400" y="2286000"/>
             <a:ext cx="274320" cy="274320"/>
           </a:xfrm>
           <a:prstGeom prst="rightArrow">
@@ -3946,7 +3940,7 @@
         <p:spPr>
           <a:xfrm>
             <a:off x="9235440" y="1645920"/>
-            <a:ext cx="2560320" cy="1828800"/>
+            <a:ext cx="2560320" cy="1645920"/>
           </a:xfrm>
           <a:prstGeom prst="roundRect">
             <a:avLst/>
@@ -3977,7 +3971,7 @@
           <a:lstStyle/>
           <a:p>
             <a:pPr algn="ctr">
-              <a:defRPr sz="1400" b="1">
+              <a:defRPr sz="1300" b="1">
                 <a:solidFill>
                   <a:srgbClr val="FFFFFF"/>
                 </a:solidFill>
@@ -4005,19 +3999,17 @@
         </p:nvSpPr>
         <p:spPr>
           <a:xfrm>
-            <a:off x="457200" y="3931920"/>
-            <a:ext cx="11155680" cy="2011680"/>
+            <a:off x="457200" y="3749039"/>
+            <a:ext cx="11155680" cy="2103120"/>
           </a:xfrm>
           <a:prstGeom prst="roundRect">
             <a:avLst/>
           </a:prstGeom>
           <a:solidFill>
-            <a:srgbClr val="0A1E38"/>
+            <a:srgbClr val="11273F"/>
           </a:solidFill>
-          <a:ln w="25400">
-            <a:solidFill>
-              <a:srgbClr val="29B5E8"/>
-            </a:solidFill>
+          <a:ln>
+            <a:noFill/>
           </a:ln>
         </p:spPr>
         <p:style>
@@ -4050,8 +4042,8 @@
         </p:nvSpPr>
         <p:spPr>
           <a:xfrm>
-            <a:off x="914400" y="4023360"/>
-            <a:ext cx="10241280" cy="1828800"/>
+            <a:off x="914400" y="3840480"/>
+            <a:ext cx="10241280" cy="1920240"/>
           </a:xfrm>
           <a:prstGeom prst="rect">
             <a:avLst/>
@@ -4065,7 +4057,7 @@
           <a:lstStyle/>
           <a:p>
             <a:pPr algn="l">
-              <a:defRPr sz="1400" b="0">
+              <a:defRPr sz="1300" b="0">
                 <a:solidFill>
                   <a:srgbClr val="FFFFFF"/>
                 </a:solidFill>
@@ -4077,11 +4069,15 @@
             <a:br/>
             <a:br/>
             <a:r>
-              <a:t>Oracle says no risk → add manufacturing + external context → same question,</a:t>
+              <a:t>Oracle says no risk → add manufacturing + external context →</a:t>
             </a:r>
             <a:br/>
             <a:r>
-              <a:t>real risk surfaced and quantified → agent recommends cross-site action →</a:t>
+              <a:t>same question, real risk surfaced and quantified in MW →</a:t>
+            </a:r>
+            <a:br/>
+            <a:r>
+              <a:t>agent recommends cross-site action →</a:t>
             </a:r>
             <a:br/>
             <a:r>
@@ -4104,7 +4100,7 @@
     <p:bg>
       <p:bgPr>
         <a:solidFill>
-          <a:srgbClr val="05142B"/>
+          <a:srgbClr val="F8FAFC"/>
         </a:solidFill>
         <a:effectLst/>
       </p:bgPr>
@@ -4118,7 +4114,7 @@
       <p:grpSpPr/>
       <p:pic>
         <p:nvPicPr>
-          <p:cNvPr id="2" name="Picture 1" descr="snowflake_logo_white.png"/>
+          <p:cNvPr id="2" name="Picture 1" descr="sf_logo_combined.png"/>
           <p:cNvPicPr>
             <a:picLocks noChangeAspect="1"/>
           </p:cNvPicPr>
@@ -4132,8 +4128,8 @@
         </p:blipFill>
         <p:spPr>
           <a:xfrm>
-            <a:off x="457200" y="274320"/>
-            <a:ext cx="457200" cy="457200"/>
+            <a:off x="365760" y="228600"/>
+            <a:ext cx="2468880" cy="411480"/>
           </a:xfrm>
           <a:prstGeom prst="rect">
             <a:avLst/>
@@ -4148,8 +4144,8 @@
         </p:nvSpPr>
         <p:spPr>
           <a:xfrm>
-            <a:off x="457200" y="6446520"/>
-            <a:ext cx="11247120" cy="27432"/>
+            <a:off x="0" y="6583680"/>
+            <a:ext cx="12191695" cy="36576"/>
           </a:xfrm>
           <a:prstGeom prst="rect">
             <a:avLst/>
@@ -4191,7 +4187,7 @@
         </p:nvSpPr>
         <p:spPr>
           <a:xfrm>
-            <a:off x="731520" y="731520"/>
+            <a:off x="731520" y="777240"/>
             <a:ext cx="10058400" cy="548640"/>
           </a:xfrm>
           <a:prstGeom prst="rect">
@@ -4206,9 +4202,9 @@
           <a:lstStyle/>
           <a:p>
             <a:pPr algn="l">
-              <a:defRPr sz="3200" b="1">
-                <a:solidFill>
-                  <a:srgbClr val="29B5E8"/>
+              <a:defRPr sz="3000" b="1">
+                <a:solidFill>
+                  <a:srgbClr val="11273F"/>
                 </a:solidFill>
               </a:defRPr>
             </a:pPr>
@@ -4227,7 +4223,7 @@
         <p:spPr>
           <a:xfrm>
             <a:off x="914400" y="1463040"/>
-            <a:ext cx="2286000" cy="457200"/>
+            <a:ext cx="2560320" cy="457200"/>
           </a:xfrm>
           <a:prstGeom prst="rect">
             <a:avLst/>
@@ -4241,7 +4237,7 @@
           <a:lstStyle/>
           <a:p>
             <a:pPr algn="l">
-              <a:defRPr sz="1200" b="1">
+              <a:defRPr sz="1100" b="1">
                 <a:solidFill>
                   <a:srgbClr val="29B5E8"/>
                 </a:solidFill>
@@ -4261,7 +4257,7 @@
         </p:nvSpPr>
         <p:spPr>
           <a:xfrm>
-            <a:off x="3200400" y="1463040"/>
+            <a:off x="3474720" y="1463040"/>
             <a:ext cx="8229600" cy="457200"/>
           </a:xfrm>
           <a:prstGeom prst="rect">
@@ -4276,9 +4272,9 @@
           <a:lstStyle/>
           <a:p>
             <a:pPr algn="l">
-              <a:defRPr sz="1200" b="0">
-                <a:solidFill>
-                  <a:srgbClr val="FFFFFF"/>
+              <a:defRPr sz="1100" b="0">
+                <a:solidFill>
+                  <a:srgbClr val="333333"/>
                 </a:solidFill>
               </a:defRPr>
             </a:pPr>
@@ -4296,8 +4292,8 @@
         </p:nvSpPr>
         <p:spPr>
           <a:xfrm>
-            <a:off x="914400" y="2011680"/>
-            <a:ext cx="2286000" cy="457200"/>
+            <a:off x="914400" y="2039112"/>
+            <a:ext cx="2560320" cy="457200"/>
           </a:xfrm>
           <a:prstGeom prst="rect">
             <a:avLst/>
@@ -4311,7 +4307,7 @@
           <a:lstStyle/>
           <a:p>
             <a:pPr algn="l">
-              <a:defRPr sz="1200" b="1">
+              <a:defRPr sz="1100" b="1">
                 <a:solidFill>
                   <a:srgbClr val="29B5E8"/>
                 </a:solidFill>
@@ -4331,7 +4327,7 @@
         </p:nvSpPr>
         <p:spPr>
           <a:xfrm>
-            <a:off x="3200400" y="2011680"/>
+            <a:off x="3474720" y="2039112"/>
             <a:ext cx="8229600" cy="457200"/>
           </a:xfrm>
           <a:prstGeom prst="rect">
@@ -4346,14 +4342,14 @@
           <a:lstStyle/>
           <a:p>
             <a:pPr algn="l">
-              <a:defRPr sz="1200" b="0">
-                <a:solidFill>
-                  <a:srgbClr val="FFFFFF"/>
-                </a:solidFill>
-              </a:defRPr>
-            </a:pPr>
-            <a:r>
-              <a:t>Core message slide 2</a:t>
+              <a:defRPr sz="1100" b="0">
+                <a:solidFill>
+                  <a:srgbClr val="333333"/>
+                </a:solidFill>
+              </a:defRPr>
+            </a:pPr>
+            <a:r>
+              <a:t>Lead and close with the core message (Slide 2)</a:t>
             </a:r>
           </a:p>
         </p:txBody>
@@ -4366,8 +4362,8 @@
         </p:nvSpPr>
         <p:spPr>
           <a:xfrm>
-            <a:off x="914400" y="2560320"/>
-            <a:ext cx="2286000" cy="457200"/>
+            <a:off x="914400" y="2615184"/>
+            <a:ext cx="2560320" cy="457200"/>
           </a:xfrm>
           <a:prstGeom prst="rect">
             <a:avLst/>
@@ -4381,7 +4377,7 @@
           <a:lstStyle/>
           <a:p>
             <a:pPr algn="l">
-              <a:defRPr sz="1200" b="1">
+              <a:defRPr sz="1100" b="1">
                 <a:solidFill>
                   <a:srgbClr val="29B5E8"/>
                 </a:solidFill>
@@ -4401,7 +4397,7 @@
         </p:nvSpPr>
         <p:spPr>
           <a:xfrm>
-            <a:off x="3200400" y="2560320"/>
+            <a:off x="3474720" y="2615184"/>
             <a:ext cx="8229600" cy="457200"/>
           </a:xfrm>
           <a:prstGeom prst="rect">
@@ -4416,14 +4412,14 @@
           <a:lstStyle/>
           <a:p>
             <a:pPr algn="l">
-              <a:defRPr sz="1200" b="0">
-                <a:solidFill>
-                  <a:srgbClr val="FFFFFF"/>
-                </a:solidFill>
-              </a:defRPr>
-            </a:pPr>
-            <a:r>
-              <a:t>Data boundary, not failure</a:t>
+              <a:defRPr sz="1100" b="0">
+                <a:solidFill>
+                  <a:srgbClr val="333333"/>
+                </a:solidFill>
+              </a:defRPr>
+            </a:pPr>
+            <a:r>
+              <a:t>"That's a data boundary, not a failure" — say it out loud</a:t>
             </a:r>
           </a:p>
         </p:txBody>
@@ -4436,8 +4432,8 @@
         </p:nvSpPr>
         <p:spPr>
           <a:xfrm>
-            <a:off x="914400" y="3108960"/>
-            <a:ext cx="2286000" cy="457200"/>
+            <a:off x="914400" y="3191256"/>
+            <a:ext cx="2560320" cy="457200"/>
           </a:xfrm>
           <a:prstGeom prst="rect">
             <a:avLst/>
@@ -4451,7 +4447,7 @@
           <a:lstStyle/>
           <a:p>
             <a:pPr algn="l">
-              <a:defRPr sz="1200" b="1">
+              <a:defRPr sz="1100" b="1">
                 <a:solidFill>
                   <a:srgbClr val="29B5E8"/>
                 </a:solidFill>
@@ -4471,7 +4467,7 @@
         </p:nvSpPr>
         <p:spPr>
           <a:xfrm>
-            <a:off x="3200400" y="3108960"/>
+            <a:off x="3474720" y="3191256"/>
             <a:ext cx="8229600" cy="457200"/>
           </a:xfrm>
           <a:prstGeom prst="rect">
@@ -4486,14 +4482,14 @@
           <a:lstStyle/>
           <a:p>
             <a:pPr algn="l">
-              <a:defRPr sz="1200" b="0">
-                <a:solidFill>
-                  <a:srgbClr val="FFFFFF"/>
-                </a:solidFill>
-              </a:defRPr>
-            </a:pPr>
-            <a:r>
-              <a:t>External = simulated Marketplace</a:t>
+              <a:defRPr sz="1100" b="0">
+                <a:solidFill>
+                  <a:srgbClr val="333333"/>
+                </a:solidFill>
+              </a:defRPr>
+            </a:pPr>
+            <a:r>
+              <a:t>"External signal is simulated; in production = live Marketplace"</a:t>
             </a:r>
           </a:p>
         </p:txBody>
@@ -4506,8 +4502,8 @@
         </p:nvSpPr>
         <p:spPr>
           <a:xfrm>
-            <a:off x="914400" y="3657600"/>
-            <a:ext cx="2286000" cy="457200"/>
+            <a:off x="914400" y="3767328"/>
+            <a:ext cx="2560320" cy="457200"/>
           </a:xfrm>
           <a:prstGeom prst="rect">
             <a:avLst/>
@@ -4521,7 +4517,7 @@
           <a:lstStyle/>
           <a:p>
             <a:pPr algn="l">
-              <a:defRPr sz="1200" b="1">
+              <a:defRPr sz="1100" b="1">
                 <a:solidFill>
                   <a:srgbClr val="29B5E8"/>
                 </a:solidFill>
@@ -4541,7 +4537,7 @@
         </p:nvSpPr>
         <p:spPr>
           <a:xfrm>
-            <a:off x="3200400" y="3657600"/>
+            <a:off x="3474720" y="3767328"/>
             <a:ext cx="8229600" cy="457200"/>
           </a:xfrm>
           <a:prstGeom prst="rect">
@@ -4556,14 +4552,14 @@
           <a:lstStyle/>
           <a:p>
             <a:pPr algn="l">
-              <a:defRPr sz="1200" b="0">
-                <a:solidFill>
-                  <a:srgbClr val="FFFFFF"/>
-                </a:solidFill>
-              </a:defRPr>
-            </a:pPr>
-            <a:r>
-              <a:t>MW and $ always</a:t>
+              <a:defRPr sz="1100" b="0">
+                <a:solidFill>
+                  <a:srgbClr val="333333"/>
+                </a:solidFill>
+              </a:defRPr>
+            </a:pPr>
+            <a:r>
+              <a:t>Always land in MW and $ — that makes the CSCO lean in</a:t>
             </a:r>
           </a:p>
         </p:txBody>
@@ -4576,8 +4572,8 @@
         </p:nvSpPr>
         <p:spPr>
           <a:xfrm>
-            <a:off x="914400" y="4206240"/>
-            <a:ext cx="2286000" cy="457200"/>
+            <a:off x="914400" y="4343400"/>
+            <a:ext cx="2560320" cy="457200"/>
           </a:xfrm>
           <a:prstGeom prst="rect">
             <a:avLst/>
@@ -4591,7 +4587,7 @@
           <a:lstStyle/>
           <a:p>
             <a:pPr algn="l">
-              <a:defRPr sz="1200" b="1">
+              <a:defRPr sz="1100" b="1">
                 <a:solidFill>
                   <a:srgbClr val="29B5E8"/>
                 </a:solidFill>
@@ -4611,7 +4607,7 @@
         </p:nvSpPr>
         <p:spPr>
           <a:xfrm>
-            <a:off x="3200400" y="4206240"/>
+            <a:off x="3474720" y="4343400"/>
             <a:ext cx="8229600" cy="457200"/>
           </a:xfrm>
           <a:prstGeom prst="rect">
@@ -4626,14 +4622,14 @@
           <a:lstStyle/>
           <a:p>
             <a:pPr algn="l">
-              <a:defRPr sz="1200" b="0">
-                <a:solidFill>
-                  <a:srgbClr val="FFFFFF"/>
-                </a:solidFill>
-              </a:defRPr>
-            </a:pPr>
-            <a:r>
-              <a:t>Model choice, cost control, human loop</a:t>
+              <a:defRPr sz="1100" b="0">
+                <a:solidFill>
+                  <a:srgbClr val="333333"/>
+                </a:solidFill>
+              </a:defRPr>
+            </a:pPr>
+            <a:r>
+              <a:t>"You choose the model, control the cost, human in the loop"</a:t>
             </a:r>
           </a:p>
         </p:txBody>
@@ -4646,8 +4642,8 @@
         </p:nvSpPr>
         <p:spPr>
           <a:xfrm>
-            <a:off x="914400" y="4754879"/>
-            <a:ext cx="2286000" cy="457200"/>
+            <a:off x="914400" y="4919472"/>
+            <a:ext cx="2560320" cy="457200"/>
           </a:xfrm>
           <a:prstGeom prst="rect">
             <a:avLst/>
@@ -4661,14 +4657,14 @@
           <a:lstStyle/>
           <a:p>
             <a:pPr algn="l">
-              <a:defRPr sz="1200" b="1">
+              <a:defRPr sz="1100" b="1">
                 <a:solidFill>
                   <a:srgbClr val="29B5E8"/>
                 </a:solidFill>
               </a:defRPr>
             </a:pPr>
             <a:r>
-              <a:t>Label</a:t>
+              <a:t>Label Data</a:t>
             </a:r>
           </a:p>
         </p:txBody>
@@ -4681,7 +4677,7 @@
         </p:nvSpPr>
         <p:spPr>
           <a:xfrm>
-            <a:off x="3200400" y="4754879"/>
+            <a:off x="3474720" y="4919472"/>
             <a:ext cx="8229600" cy="457200"/>
           </a:xfrm>
           <a:prstGeom prst="rect">
@@ -4696,14 +4692,14 @@
           <a:lstStyle/>
           <a:p>
             <a:pPr algn="l">
-              <a:defRPr sz="1200" b="0">
-                <a:solidFill>
-                  <a:srgbClr val="FFFFFF"/>
-                </a:solidFill>
-              </a:defRPr>
-            </a:pPr>
-            <a:r>
-              <a:t>Plants real, data simulated</a:t>
+              <a:defRPr sz="1100" b="0">
+                <a:solidFill>
+                  <a:srgbClr val="333333"/>
+                </a:solidFill>
+              </a:defRPr>
+            </a:pPr>
+            <a:r>
+              <a:t>Plants are real (AL, OH, LA). Data is simulated but labeled.</a:t>
             </a:r>
           </a:p>
         </p:txBody>
@@ -4716,8 +4712,8 @@
         </p:nvSpPr>
         <p:spPr>
           <a:xfrm>
-            <a:off x="914400" y="5303520"/>
-            <a:ext cx="2286000" cy="457200"/>
+            <a:off x="914400" y="5495544"/>
+            <a:ext cx="2560320" cy="457200"/>
           </a:xfrm>
           <a:prstGeom prst="rect">
             <a:avLst/>
@@ -4731,7 +4727,7 @@
           <a:lstStyle/>
           <a:p>
             <a:pPr algn="l">
-              <a:defRPr sz="1200" b="1">
+              <a:defRPr sz="1100" b="1">
                 <a:solidFill>
                   <a:srgbClr val="29B5E8"/>
                 </a:solidFill>
@@ -4751,7 +4747,7 @@
         </p:nvSpPr>
         <p:spPr>
           <a:xfrm>
-            <a:off x="3200400" y="5303520"/>
+            <a:off x="3474720" y="5495544"/>
             <a:ext cx="8229600" cy="457200"/>
           </a:xfrm>
           <a:prstGeom prst="rect">
@@ -4766,14 +4762,14 @@
           <a:lstStyle/>
           <a:p>
             <a:pPr algn="l">
-              <a:defRPr sz="1200" b="0">
-                <a:solidFill>
-                  <a:srgbClr val="FFFFFF"/>
-                </a:solidFill>
-              </a:defRPr>
-            </a:pPr>
-            <a:r>
-              <a:t>Glass + tellurium = public risk</a:t>
+              <a:defRPr sz="1100" b="0">
+                <a:solidFill>
+                  <a:srgbClr val="333333"/>
+                </a:solidFill>
+              </a:defRPr>
+            </a:pPr>
+            <a:r>
+              <a:t>Substrate glass + tellurium = publicly disclosed risk factors</a:t>
             </a:r>
           </a:p>
         </p:txBody>
@@ -4792,7 +4788,7 @@
     <p:bg>
       <p:bgPr>
         <a:solidFill>
-          <a:srgbClr val="05142B"/>
+          <a:srgbClr val="11273F"/>
         </a:solidFill>
         <a:effectLst/>
       </p:bgPr>
@@ -4806,7 +4802,7 @@
       <p:grpSpPr/>
       <p:pic>
         <p:nvPicPr>
-          <p:cNvPr id="2" name="Picture 1" descr="snowflake_logo_white.png"/>
+          <p:cNvPr id="2" name="Picture 1" descr="sf_logo_combined.png"/>
           <p:cNvPicPr>
             <a:picLocks noChangeAspect="1"/>
           </p:cNvPicPr>
@@ -4820,8 +4816,8 @@
         </p:blipFill>
         <p:spPr>
           <a:xfrm>
-            <a:off x="457200" y="274320"/>
-            <a:ext cx="457200" cy="457200"/>
+            <a:off x="365760" y="228600"/>
+            <a:ext cx="2468880" cy="411480"/>
           </a:xfrm>
           <a:prstGeom prst="rect">
             <a:avLst/>
@@ -4836,8 +4832,8 @@
         </p:nvSpPr>
         <p:spPr>
           <a:xfrm>
-            <a:off x="457200" y="6446520"/>
-            <a:ext cx="11247120" cy="27432"/>
+            <a:off x="0" y="6583680"/>
+            <a:ext cx="12191695" cy="36576"/>
           </a:xfrm>
           <a:prstGeom prst="rect">
             <a:avLst/>
@@ -4873,22 +4869,22 @@
       </p:sp>
       <p:pic>
         <p:nvPicPr>
-          <p:cNvPr id="4" name="Picture 3" descr="snowflake_logo_white.png"/>
+          <p:cNvPr id="4" name="Picture 3" descr="sf_icon_400.png"/>
           <p:cNvPicPr>
             <a:picLocks noChangeAspect="1"/>
           </p:cNvPicPr>
           <p:nvPr/>
         </p:nvPicPr>
         <p:blipFill>
-          <a:blip r:embed="rId2"/>
+          <a:blip r:embed="rId3"/>
           <a:stretch>
             <a:fillRect/>
           </a:stretch>
         </p:blipFill>
         <p:spPr>
           <a:xfrm>
-            <a:off x="8229600" y="1828800"/>
-            <a:ext cx="3200400" cy="3200400"/>
+            <a:off x="8686800" y="1371600"/>
+            <a:ext cx="6445110" cy="3657600"/>
           </a:xfrm>
           <a:prstGeom prst="rect">
             <a:avLst/>
@@ -4903,7 +4899,7 @@
         </p:nvSpPr>
         <p:spPr>
           <a:xfrm>
-            <a:off x="731520" y="731520"/>
+            <a:off x="731520" y="777240"/>
             <a:ext cx="10058400" cy="548640"/>
           </a:xfrm>
           <a:prstGeom prst="rect">
@@ -4918,7 +4914,7 @@
           <a:lstStyle/>
           <a:p>
             <a:pPr algn="l">
-              <a:defRPr sz="3200" b="1">
+              <a:defRPr sz="3000" b="1">
                 <a:solidFill>
                   <a:srgbClr val="29B5E8"/>
                 </a:solidFill>
@@ -4953,7 +4949,7 @@
           <a:lstStyle/>
           <a:p>
             <a:pPr algn="l">
-              <a:defRPr sz="1300" b="0">
+              <a:defRPr sz="1200" b="0">
                 <a:solidFill>
                   <a:srgbClr val="FFFFFF"/>
                 </a:solidFill>
@@ -4977,11 +4973,7 @@
             </a:r>
             <a:br/>
             <a:r>
-              <a:t>  11 tools | 15 sample questions</a:t>
-            </a:r>
-            <a:br/>
-            <a:r>
-              <a:t>  Budget: 60s / 32K tokens</a:t>
+              <a:t>  11 tools | 15 sample questions | 60s / 32K</a:t>
             </a:r>
             <a:br/>
             <a:br/>
@@ -4998,24 +4990,28 @@
             </a:r>
             <a:br/>
             <a:r>
-              <a:t>  RISK_INTELLIGENCE_SV (8 tables + ext)</a:t>
+              <a:t>  RISK_INTELLIGENCE_SV (8 tables + ext signals)</a:t>
             </a:r>
             <a:br/>
             <a:br/>
             <a:r>
-              <a:t>Scenario Data:</a:t>
+              <a:t>Key Scenario Data:</a:t>
             </a:r>
             <a:br/>
             <a:r>
-              <a:t>  Alabama glass: 18d | Ohio: 45d</a:t>
+              <a:t>  Alabama glass: 18 days (tight)</a:t>
             </a:r>
             <a:br/>
             <a:r>
-              <a:t>  ABC Glass OTD: 97%</a:t>
+              <a:t>  Ohio glass: 45 days (surplus)</a:t>
             </a:r>
             <a:br/>
             <a:r>
-              <a:t>  External: -19% vol, +71% dwell</a:t>
+              <a:t>  ABC Glass OTD: 97% historical</a:t>
+            </a:r>
+            <a:br/>
+            <a:r>
+              <a:t>  External: -19% vol, +71% dwell time</a:t>
             </a:r>
             <a:br/>
             <a:br/>
@@ -5039,7 +5035,7 @@
     <p:bg>
       <p:bgPr>
         <a:solidFill>
-          <a:srgbClr val="05142B"/>
+          <a:srgbClr val="F8FAFC"/>
         </a:solidFill>
         <a:effectLst/>
       </p:bgPr>
@@ -5053,7 +5049,7 @@
       <p:grpSpPr/>
       <p:pic>
         <p:nvPicPr>
-          <p:cNvPr id="2" name="Picture 1" descr="snowflake_logo_white.png"/>
+          <p:cNvPr id="2" name="Picture 1" descr="sf_logo_combined.png"/>
           <p:cNvPicPr>
             <a:picLocks noChangeAspect="1"/>
           </p:cNvPicPr>
@@ -5067,8 +5063,8 @@
         </p:blipFill>
         <p:spPr>
           <a:xfrm>
-            <a:off x="457200" y="274320"/>
-            <a:ext cx="457200" cy="457200"/>
+            <a:off x="365760" y="228600"/>
+            <a:ext cx="2468880" cy="411480"/>
           </a:xfrm>
           <a:prstGeom prst="rect">
             <a:avLst/>
@@ -5083,8 +5079,8 @@
         </p:nvSpPr>
         <p:spPr>
           <a:xfrm>
-            <a:off x="457200" y="6446520"/>
-            <a:ext cx="11247120" cy="27432"/>
+            <a:off x="0" y="6583680"/>
+            <a:ext cx="12191695" cy="36576"/>
           </a:xfrm>
           <a:prstGeom prst="rect">
             <a:avLst/>
@@ -5127,7 +5123,7 @@
         <p:spPr>
           <a:xfrm>
             <a:off x="731520" y="914400"/>
-            <a:ext cx="10058400" cy="731520"/>
+            <a:ext cx="10058400" cy="640080"/>
           </a:xfrm>
           <a:prstGeom prst="rect">
             <a:avLst/>
@@ -5141,9 +5137,9 @@
           <a:lstStyle/>
           <a:p>
             <a:pPr algn="l">
-              <a:defRPr sz="3600" b="1">
-                <a:solidFill>
-                  <a:srgbClr val="29B5E8"/>
+              <a:defRPr sz="3400" b="1">
+                <a:solidFill>
+                  <a:srgbClr val="11273F"/>
                 </a:solidFill>
               </a:defRPr>
             </a:pPr>
@@ -5161,19 +5157,17 @@
         </p:nvSpPr>
         <p:spPr>
           <a:xfrm>
-            <a:off x="731520" y="1828800"/>
-            <a:ext cx="10515600" cy="3474720"/>
+            <a:off x="731520" y="1737360"/>
+            <a:ext cx="10515600" cy="3657600"/>
           </a:xfrm>
           <a:prstGeom prst="roundRect">
             <a:avLst/>
           </a:prstGeom>
           <a:solidFill>
-            <a:srgbClr val="0A1E38"/>
+            <a:srgbClr val="11273F"/>
           </a:solidFill>
-          <a:ln w="25400">
-            <a:solidFill>
-              <a:srgbClr val="29B5E8"/>
-            </a:solidFill>
+          <a:ln>
+            <a:noFill/>
           </a:ln>
         </p:spPr>
         <p:style>
@@ -5206,7 +5200,7 @@
         </p:nvSpPr>
         <p:spPr>
           <a:xfrm>
-            <a:off x="1188720" y="2103120"/>
+            <a:off x="1188720" y="2011680"/>
             <a:ext cx="9601200" cy="3200400"/>
           </a:xfrm>
           <a:prstGeom prst="rect">
@@ -5248,81 +5242,9 @@
           </a:p>
         </p:txBody>
       </p:sp>
-      <p:pic>
-        <p:nvPicPr>
-          <p:cNvPr id="7" name="Picture 6" descr="icon_oracle.png"/>
-          <p:cNvPicPr>
-            <a:picLocks noChangeAspect="1"/>
-          </p:cNvPicPr>
-          <p:nvPr/>
-        </p:nvPicPr>
-        <p:blipFill>
-          <a:blip r:embed="rId3"/>
-          <a:stretch>
-            <a:fillRect/>
-          </a:stretch>
-        </p:blipFill>
-        <p:spPr>
-          <a:xfrm>
-            <a:off x="9601200" y="2103120"/>
-            <a:ext cx="548640" cy="548640"/>
-          </a:xfrm>
-          <a:prstGeom prst="rect">
-            <a:avLst/>
-          </a:prstGeom>
-        </p:spPr>
-      </p:pic>
-      <p:pic>
-        <p:nvPicPr>
-          <p:cNvPr id="8" name="Picture 7" descr="icon_mfg.png"/>
-          <p:cNvPicPr>
-            <a:picLocks noChangeAspect="1"/>
-          </p:cNvPicPr>
-          <p:nvPr/>
-        </p:nvPicPr>
-        <p:blipFill>
-          <a:blip r:embed="rId4"/>
-          <a:stretch>
-            <a:fillRect/>
-          </a:stretch>
-        </p:blipFill>
-        <p:spPr>
-          <a:xfrm>
-            <a:off x="9601200" y="2926080"/>
-            <a:ext cx="548640" cy="548640"/>
-          </a:xfrm>
-          <a:prstGeom prst="rect">
-            <a:avLst/>
-          </a:prstGeom>
-        </p:spPr>
-      </p:pic>
-      <p:pic>
-        <p:nvPicPr>
-          <p:cNvPr id="9" name="Picture 8" descr="icon_external.png"/>
-          <p:cNvPicPr>
-            <a:picLocks noChangeAspect="1"/>
-          </p:cNvPicPr>
-          <p:nvPr/>
-        </p:nvPicPr>
-        <p:blipFill>
-          <a:blip r:embed="rId5"/>
-          <a:stretch>
-            <a:fillRect/>
-          </a:stretch>
-        </p:blipFill>
-        <p:spPr>
-          <a:xfrm>
-            <a:off x="9601200" y="3749039"/>
-            <a:ext cx="548640" cy="548640"/>
-          </a:xfrm>
-          <a:prstGeom prst="rect">
-            <a:avLst/>
-          </a:prstGeom>
-        </p:spPr>
-      </p:pic>
-      <p:sp>
-        <p:nvSpPr>
-          <p:cNvPr id="10" name="TextBox 9"/>
+      <p:sp>
+        <p:nvSpPr>
+          <p:cNvPr id="7" name="TextBox 6"/>
           <p:cNvSpPr txBox="1"/>
           <p:nvPr/>
         </p:nvSpPr>
@@ -5369,7 +5291,7 @@
     <p:bg>
       <p:bgPr>
         <a:solidFill>
-          <a:srgbClr val="05142B"/>
+          <a:srgbClr val="F8FAFC"/>
         </a:solidFill>
         <a:effectLst/>
       </p:bgPr>
@@ -5383,7 +5305,7 @@
       <p:grpSpPr/>
       <p:pic>
         <p:nvPicPr>
-          <p:cNvPr id="2" name="Picture 1" descr="snowflake_logo_white.png"/>
+          <p:cNvPr id="2" name="Picture 1" descr="sf_logo_combined.png"/>
           <p:cNvPicPr>
             <a:picLocks noChangeAspect="1"/>
           </p:cNvPicPr>
@@ -5397,8 +5319,8 @@
         </p:blipFill>
         <p:spPr>
           <a:xfrm>
-            <a:off x="457200" y="274320"/>
-            <a:ext cx="457200" cy="457200"/>
+            <a:off x="365760" y="228600"/>
+            <a:ext cx="2468880" cy="411480"/>
           </a:xfrm>
           <a:prstGeom prst="rect">
             <a:avLst/>
@@ -5413,8 +5335,8 @@
         </p:nvSpPr>
         <p:spPr>
           <a:xfrm>
-            <a:off x="457200" y="6446520"/>
-            <a:ext cx="11247120" cy="27432"/>
+            <a:off x="0" y="6583680"/>
+            <a:ext cx="12191695" cy="36576"/>
           </a:xfrm>
           <a:prstGeom prst="rect">
             <a:avLst/>
@@ -5457,7 +5379,7 @@
         <p:spPr>
           <a:xfrm>
             <a:off x="731520" y="822960"/>
-            <a:ext cx="10058400" cy="731520"/>
+            <a:ext cx="10058400" cy="640080"/>
           </a:xfrm>
           <a:prstGeom prst="rect">
             <a:avLst/>
@@ -5471,9 +5393,9 @@
           <a:lstStyle/>
           <a:p>
             <a:pPr algn="l">
-              <a:defRPr sz="3600" b="1">
-                <a:solidFill>
-                  <a:srgbClr val="29B5E8"/>
+              <a:defRPr sz="3400" b="1">
+                <a:solidFill>
+                  <a:srgbClr val="11273F"/>
                 </a:solidFill>
               </a:defRPr>
             </a:pPr>
@@ -5491,8 +5413,8 @@
         </p:nvSpPr>
         <p:spPr>
           <a:xfrm>
-            <a:off x="731520" y="1554480"/>
-            <a:ext cx="10058400" cy="457200"/>
+            <a:off x="731520" y="1463040"/>
+            <a:ext cx="10058400" cy="365760"/>
           </a:xfrm>
           <a:prstGeom prst="rect">
             <a:avLst/>
@@ -5506,9 +5428,9 @@
           <a:lstStyle/>
           <a:p>
             <a:pPr algn="l">
-              <a:defRPr sz="1500" b="0">
-                <a:solidFill>
-                  <a:srgbClr val="8E9EAB"/>
+              <a:defRPr sz="1400" b="0">
+                <a:solidFill>
+                  <a:srgbClr val="6B7B8D"/>
                 </a:solidFill>
               </a:defRPr>
             </a:pPr>
@@ -5526,19 +5448,17 @@
         </p:nvSpPr>
         <p:spPr>
           <a:xfrm>
-            <a:off x="548640" y="2286000"/>
-            <a:ext cx="10972800" cy="1463040"/>
+            <a:off x="548640" y="2103120"/>
+            <a:ext cx="10972800" cy="1371600"/>
           </a:xfrm>
           <a:prstGeom prst="roundRect">
             <a:avLst/>
           </a:prstGeom>
           <a:solidFill>
-            <a:srgbClr val="0A1E38"/>
+            <a:srgbClr val="11273F"/>
           </a:solidFill>
-          <a:ln w="25400">
-            <a:solidFill>
-              <a:srgbClr val="29B5E8"/>
-            </a:solidFill>
+          <a:ln>
+            <a:noFill/>
           </a:ln>
         </p:spPr>
         <p:style>
@@ -5571,7 +5491,7 @@
         </p:nvSpPr>
         <p:spPr>
           <a:xfrm>
-            <a:off x="1097280" y="2560320"/>
+            <a:off x="1097280" y="2286000"/>
             <a:ext cx="10058400" cy="1097280"/>
           </a:xfrm>
           <a:prstGeom prst="rect">
@@ -5586,7 +5506,7 @@
           <a:lstStyle/>
           <a:p>
             <a:pPr algn="ctr">
-              <a:defRPr sz="2200" b="1">
+              <a:defRPr sz="2100" b="1">
                 <a:solidFill>
                   <a:srgbClr val="FFFFFF"/>
                 </a:solidFill>
@@ -5602,30 +5522,49 @@
           </a:p>
         </p:txBody>
       </p:sp>
-      <p:pic>
-        <p:nvPicPr>
-          <p:cNvPr id="8" name="Picture 7" descr="icon_check.png"/>
-          <p:cNvPicPr>
-            <a:picLocks noChangeAspect="1"/>
-          </p:cNvPicPr>
-          <p:nvPr/>
-        </p:nvPicPr>
-        <p:blipFill>
-          <a:blip r:embed="rId3"/>
-          <a:stretch>
-            <a:fillRect/>
-          </a:stretch>
-        </p:blipFill>
-        <p:spPr>
-          <a:xfrm>
-            <a:off x="914400" y="4206240"/>
+      <p:sp>
+        <p:nvSpPr>
+          <p:cNvPr id="8" name="Rounded Rectangle 7"/>
+          <p:cNvSpPr/>
+          <p:nvPr/>
+        </p:nvSpPr>
+        <p:spPr>
+          <a:xfrm>
+            <a:off x="731520" y="3931920"/>
             <a:ext cx="457200" cy="457200"/>
           </a:xfrm>
-          <a:prstGeom prst="rect">
-            <a:avLst/>
-          </a:prstGeom>
-        </p:spPr>
-      </p:pic>
+          <a:prstGeom prst="roundRect">
+            <a:avLst/>
+          </a:prstGeom>
+          <a:solidFill>
+            <a:srgbClr val="2E7D32"/>
+          </a:solidFill>
+          <a:ln>
+            <a:noFill/>
+          </a:ln>
+        </p:spPr>
+        <p:style>
+          <a:lnRef idx="1">
+            <a:schemeClr val="accent1"/>
+          </a:lnRef>
+          <a:fillRef idx="3">
+            <a:schemeClr val="accent1"/>
+          </a:fillRef>
+          <a:effectRef idx="2">
+            <a:schemeClr val="accent1"/>
+          </a:effectRef>
+          <a:fontRef idx="minor">
+            <a:schemeClr val="lt1"/>
+          </a:fontRef>
+        </p:style>
+        <p:txBody>
+          <a:bodyPr rtlCol="0" anchor="ctr"/>
+          <a:lstStyle/>
+          <a:p>
+            <a:pPr algn="ctr"/>
+          </a:p>
+        </p:txBody>
+      </p:sp>
       <p:sp>
         <p:nvSpPr>
           <p:cNvPr id="9" name="TextBox 8"/>
@@ -5634,7 +5573,7 @@
         </p:nvSpPr>
         <p:spPr>
           <a:xfrm>
-            <a:off x="1463040" y="4206240"/>
+            <a:off x="1371600" y="3931920"/>
             <a:ext cx="9144000" cy="457200"/>
           </a:xfrm>
           <a:prstGeom prst="rect">
@@ -5649,7 +5588,7 @@
           <a:lstStyle/>
           <a:p>
             <a:pPr algn="l">
-              <a:defRPr sz="1500" b="0">
+              <a:defRPr sz="1400" b="0">
                 <a:solidFill>
                   <a:srgbClr val="2E7D32"/>
                 </a:solidFill>
@@ -5661,30 +5600,49 @@
           </a:p>
         </p:txBody>
       </p:sp>
-      <p:pic>
-        <p:nvPicPr>
-          <p:cNvPr id="10" name="Picture 9" descr="icon_alert.png"/>
-          <p:cNvPicPr>
-            <a:picLocks noChangeAspect="1"/>
-          </p:cNvPicPr>
-          <p:nvPr/>
-        </p:nvPicPr>
-        <p:blipFill>
-          <a:blip r:embed="rId4"/>
-          <a:stretch>
-            <a:fillRect/>
-          </a:stretch>
-        </p:blipFill>
-        <p:spPr>
-          <a:xfrm>
-            <a:off x="914400" y="4846320"/>
+      <p:sp>
+        <p:nvSpPr>
+          <p:cNvPr id="10" name="Rounded Rectangle 9"/>
+          <p:cNvSpPr/>
+          <p:nvPr/>
+        </p:nvSpPr>
+        <p:spPr>
+          <a:xfrm>
+            <a:off x="731520" y="4572000"/>
             <a:ext cx="457200" cy="457200"/>
           </a:xfrm>
-          <a:prstGeom prst="rect">
-            <a:avLst/>
-          </a:prstGeom>
-        </p:spPr>
-      </p:pic>
+          <a:prstGeom prst="roundRect">
+            <a:avLst/>
+          </a:prstGeom>
+          <a:solidFill>
+            <a:srgbClr val="E65100"/>
+          </a:solidFill>
+          <a:ln>
+            <a:noFill/>
+          </a:ln>
+        </p:spPr>
+        <p:style>
+          <a:lnRef idx="1">
+            <a:schemeClr val="accent1"/>
+          </a:lnRef>
+          <a:fillRef idx="3">
+            <a:schemeClr val="accent1"/>
+          </a:fillRef>
+          <a:effectRef idx="2">
+            <a:schemeClr val="accent1"/>
+          </a:effectRef>
+          <a:fontRef idx="minor">
+            <a:schemeClr val="lt1"/>
+          </a:fontRef>
+        </p:style>
+        <p:txBody>
+          <a:bodyPr rtlCol="0" anchor="ctr"/>
+          <a:lstStyle/>
+          <a:p>
+            <a:pPr algn="ctr"/>
+          </a:p>
+        </p:txBody>
+      </p:sp>
       <p:sp>
         <p:nvSpPr>
           <p:cNvPr id="11" name="TextBox 10"/>
@@ -5693,7 +5651,7 @@
         </p:nvSpPr>
         <p:spPr>
           <a:xfrm>
-            <a:off x="1463040" y="4846320"/>
+            <a:off x="1371600" y="4572000"/>
             <a:ext cx="9144000" cy="457200"/>
           </a:xfrm>
           <a:prstGeom prst="rect">
@@ -5708,7 +5666,7 @@
           <a:lstStyle/>
           <a:p>
             <a:pPr algn="l">
-              <a:defRPr sz="1500" b="0">
+              <a:defRPr sz="1400" b="0">
                 <a:solidFill>
                   <a:srgbClr val="E65100"/>
                 </a:solidFill>
@@ -5720,30 +5678,49 @@
           </a:p>
         </p:txBody>
       </p:sp>
-      <p:pic>
-        <p:nvPicPr>
-          <p:cNvPr id="12" name="Picture 11" descr="icon_transfer.png"/>
-          <p:cNvPicPr>
-            <a:picLocks noChangeAspect="1"/>
-          </p:cNvPicPr>
-          <p:nvPr/>
-        </p:nvPicPr>
-        <p:blipFill>
-          <a:blip r:embed="rId5"/>
-          <a:stretch>
-            <a:fillRect/>
-          </a:stretch>
-        </p:blipFill>
-        <p:spPr>
-          <a:xfrm>
-            <a:off x="914400" y="5486400"/>
+      <p:sp>
+        <p:nvSpPr>
+          <p:cNvPr id="12" name="Rounded Rectangle 11"/>
+          <p:cNvSpPr/>
+          <p:nvPr/>
+        </p:nvSpPr>
+        <p:spPr>
+          <a:xfrm>
+            <a:off x="731520" y="5212080"/>
             <a:ext cx="457200" cy="457200"/>
           </a:xfrm>
-          <a:prstGeom prst="rect">
-            <a:avLst/>
-          </a:prstGeom>
-        </p:spPr>
-      </p:pic>
+          <a:prstGeom prst="roundRect">
+            <a:avLst/>
+          </a:prstGeom>
+          <a:solidFill>
+            <a:srgbClr val="6A1B9A"/>
+          </a:solidFill>
+          <a:ln>
+            <a:noFill/>
+          </a:ln>
+        </p:spPr>
+        <p:style>
+          <a:lnRef idx="1">
+            <a:schemeClr val="accent1"/>
+          </a:lnRef>
+          <a:fillRef idx="3">
+            <a:schemeClr val="accent1"/>
+          </a:fillRef>
+          <a:effectRef idx="2">
+            <a:schemeClr val="accent1"/>
+          </a:effectRef>
+          <a:fontRef idx="minor">
+            <a:schemeClr val="lt1"/>
+          </a:fontRef>
+        </p:style>
+        <p:txBody>
+          <a:bodyPr rtlCol="0" anchor="ctr"/>
+          <a:lstStyle/>
+          <a:p>
+            <a:pPr algn="ctr"/>
+          </a:p>
+        </p:txBody>
+      </p:sp>
       <p:sp>
         <p:nvSpPr>
           <p:cNvPr id="13" name="TextBox 12"/>
@@ -5752,7 +5729,7 @@
         </p:nvSpPr>
         <p:spPr>
           <a:xfrm>
-            <a:off x="1463040" y="5486400"/>
+            <a:off x="1371600" y="5212080"/>
             <a:ext cx="9144000" cy="457200"/>
           </a:xfrm>
           <a:prstGeom prst="rect">
@@ -5767,7 +5744,7 @@
           <a:lstStyle/>
           <a:p>
             <a:pPr algn="l">
-              <a:defRPr sz="1500" b="0">
+              <a:defRPr sz="1400" b="0">
                 <a:solidFill>
                   <a:srgbClr val="6A1B9A"/>
                 </a:solidFill>
@@ -5793,7 +5770,7 @@
     <p:bg>
       <p:bgPr>
         <a:solidFill>
-          <a:srgbClr val="05142B"/>
+          <a:srgbClr val="F8FAFC"/>
         </a:solidFill>
         <a:effectLst/>
       </p:bgPr>
@@ -5807,7 +5784,7 @@
       <p:grpSpPr/>
       <p:pic>
         <p:nvPicPr>
-          <p:cNvPr id="2" name="Picture 1" descr="snowflake_logo_white.png"/>
+          <p:cNvPr id="2" name="Picture 1" descr="sf_logo_combined.png"/>
           <p:cNvPicPr>
             <a:picLocks noChangeAspect="1"/>
           </p:cNvPicPr>
@@ -5821,8 +5798,8 @@
         </p:blipFill>
         <p:spPr>
           <a:xfrm>
-            <a:off x="457200" y="274320"/>
-            <a:ext cx="457200" cy="457200"/>
+            <a:off x="365760" y="228600"/>
+            <a:ext cx="2468880" cy="411480"/>
           </a:xfrm>
           <a:prstGeom prst="rect">
             <a:avLst/>
@@ -5837,8 +5814,8 @@
         </p:nvSpPr>
         <p:spPr>
           <a:xfrm>
-            <a:off x="457200" y="6446520"/>
-            <a:ext cx="11247120" cy="27432"/>
+            <a:off x="0" y="6583680"/>
+            <a:ext cx="12191695" cy="36576"/>
           </a:xfrm>
           <a:prstGeom prst="rect">
             <a:avLst/>
@@ -5880,8 +5857,8 @@
         </p:nvSpPr>
         <p:spPr>
           <a:xfrm>
-            <a:off x="731520" y="731520"/>
-            <a:ext cx="1645920" cy="548640"/>
+            <a:off x="731520" y="777240"/>
+            <a:ext cx="1463040" cy="457200"/>
           </a:xfrm>
           <a:prstGeom prst="roundRect">
             <a:avLst/>
@@ -5912,7 +5889,7 @@
           <a:lstStyle/>
           <a:p>
             <a:pPr algn="ctr">
-              <a:defRPr sz="1600" b="1">
+              <a:defRPr sz="1300" b="1">
                 <a:solidFill>
                   <a:srgbClr val="FFFFFF"/>
                 </a:solidFill>
@@ -5932,8 +5909,8 @@
         </p:nvSpPr>
         <p:spPr>
           <a:xfrm>
-            <a:off x="2560320" y="731520"/>
-            <a:ext cx="8229600" cy="548640"/>
+            <a:off x="2377440" y="777240"/>
+            <a:ext cx="8229600" cy="457200"/>
           </a:xfrm>
           <a:prstGeom prst="rect">
             <a:avLst/>
@@ -5947,9 +5924,9 @@
           <a:lstStyle/>
           <a:p>
             <a:pPr algn="l">
-              <a:defRPr sz="2400" b="1">
-                <a:solidFill>
-                  <a:srgbClr val="FFFFFF"/>
+              <a:defRPr sz="2200" b="1">
+                <a:solidFill>
+                  <a:srgbClr val="11273F"/>
                 </a:solidFill>
               </a:defRPr>
             </a:pPr>
@@ -5959,51 +5936,25 @@
           </a:p>
         </p:txBody>
       </p:sp>
-      <p:pic>
-        <p:nvPicPr>
-          <p:cNvPr id="6" name="Picture 5" descr="icon_oracle.png"/>
-          <p:cNvPicPr>
-            <a:picLocks noChangeAspect="1"/>
-          </p:cNvPicPr>
-          <p:nvPr/>
-        </p:nvPicPr>
-        <p:blipFill>
-          <a:blip r:embed="rId3"/>
-          <a:stretch>
-            <a:fillRect/>
-          </a:stretch>
-        </p:blipFill>
-        <p:spPr>
-          <a:xfrm>
-            <a:off x="10515600" y="640080"/>
-            <a:ext cx="731520" cy="731520"/>
-          </a:xfrm>
-          <a:prstGeom prst="rect">
-            <a:avLst/>
-          </a:prstGeom>
-        </p:spPr>
-      </p:pic>
-      <p:sp>
-        <p:nvSpPr>
-          <p:cNvPr id="7" name="Rounded Rectangle 6"/>
+      <p:sp>
+        <p:nvSpPr>
+          <p:cNvPr id="6" name="Rounded Rectangle 5"/>
           <p:cNvSpPr/>
           <p:nvPr/>
         </p:nvSpPr>
         <p:spPr>
           <a:xfrm>
-            <a:off x="731520" y="1645920"/>
-            <a:ext cx="5303520" cy="1371600"/>
+            <a:off x="731520" y="1554480"/>
+            <a:ext cx="10515600" cy="868680"/>
           </a:xfrm>
           <a:prstGeom prst="roundRect">
             <a:avLst/>
           </a:prstGeom>
           <a:solidFill>
-            <a:srgbClr val="0A1E38"/>
+            <a:srgbClr val="FFFFFF"/>
           </a:solidFill>
-          <a:ln w="25400">
-            <a:solidFill>
-              <a:srgbClr val="29B5E8"/>
-            </a:solidFill>
+          <a:ln>
+            <a:noFill/>
           </a:ln>
         </p:spPr>
         <p:style>
@@ -6030,14 +5981,14 @@
       </p:sp>
       <p:sp>
         <p:nvSpPr>
-          <p:cNvPr id="8" name="TextBox 7"/>
+          <p:cNvPr id="7" name="TextBox 6"/>
           <p:cNvSpPr txBox="1"/>
           <p:nvPr/>
         </p:nvSpPr>
         <p:spPr>
           <a:xfrm>
-            <a:off x="1005840" y="1737360"/>
-            <a:ext cx="4754880" cy="457200"/>
+            <a:off x="1005840" y="1645920"/>
+            <a:ext cx="4572000" cy="365760"/>
           </a:xfrm>
           <a:prstGeom prst="rect">
             <a:avLst/>
@@ -6051,9 +6002,9 @@
           <a:lstStyle/>
           <a:p>
             <a:pPr algn="l">
-              <a:defRPr sz="1500" b="1">
-                <a:solidFill>
-                  <a:srgbClr val="29B5E8"/>
+              <a:defRPr sz="1400" b="1">
+                <a:solidFill>
+                  <a:srgbClr val="11273F"/>
                 </a:solidFill>
               </a:defRPr>
             </a:pPr>
@@ -6065,14 +6016,14 @@
       </p:sp>
       <p:sp>
         <p:nvSpPr>
-          <p:cNvPr id="9" name="TextBox 8"/>
+          <p:cNvPr id="8" name="TextBox 7"/>
           <p:cNvSpPr txBox="1"/>
           <p:nvPr/>
         </p:nvSpPr>
         <p:spPr>
           <a:xfrm>
-            <a:off x="1005840" y="2194560"/>
-            <a:ext cx="4754880" cy="457200"/>
+            <a:off x="1005840" y="2011680"/>
+            <a:ext cx="9144000" cy="365760"/>
           </a:xfrm>
           <a:prstGeom prst="rect">
             <a:avLst/>
@@ -6088,37 +6039,35 @@
             <a:pPr algn="l">
               <a:defRPr sz="1200" b="0">
                 <a:solidFill>
-                  <a:srgbClr val="FFFFFF"/>
-                </a:solidFill>
-              </a:defRPr>
-            </a:pPr>
-            <a:r>
-              <a:t>Primary glass | Monterrey MX</a:t>
-            </a:r>
-          </a:p>
-        </p:txBody>
-      </p:sp>
-      <p:sp>
-        <p:nvSpPr>
-          <p:cNvPr id="10" name="Rounded Rectangle 9"/>
+                  <a:srgbClr val="6B7B8D"/>
+                </a:solidFill>
+              </a:defRPr>
+            </a:pPr>
+            <a:r>
+              <a:t>Primary substrate glass supplier — Monterrey, Mexico</a:t>
+            </a:r>
+          </a:p>
+        </p:txBody>
+      </p:sp>
+      <p:sp>
+        <p:nvSpPr>
+          <p:cNvPr id="9" name="Rounded Rectangle 8"/>
           <p:cNvSpPr/>
           <p:nvPr/>
         </p:nvSpPr>
         <p:spPr>
           <a:xfrm>
-            <a:off x="6400800" y="1645920"/>
-            <a:ext cx="5303520" cy="1371600"/>
+            <a:off x="731520" y="2560320"/>
+            <a:ext cx="10515600" cy="868680"/>
           </a:xfrm>
           <a:prstGeom prst="roundRect">
             <a:avLst/>
           </a:prstGeom>
           <a:solidFill>
-            <a:srgbClr val="0A1E38"/>
+            <a:srgbClr val="F0F7FF"/>
           </a:solidFill>
-          <a:ln w="25400">
-            <a:solidFill>
-              <a:srgbClr val="2E7D32"/>
-            </a:solidFill>
+          <a:ln>
+            <a:noFill/>
           </a:ln>
         </p:spPr>
         <p:style>
@@ -6145,14 +6094,14 @@
       </p:sp>
       <p:sp>
         <p:nvSpPr>
-          <p:cNvPr id="11" name="TextBox 10"/>
+          <p:cNvPr id="10" name="TextBox 9"/>
           <p:cNvSpPr txBox="1"/>
           <p:nvPr/>
         </p:nvSpPr>
         <p:spPr>
           <a:xfrm>
-            <a:off x="6675120" y="1737360"/>
-            <a:ext cx="4754880" cy="457200"/>
+            <a:off x="1005840" y="2651760"/>
+            <a:ext cx="4572000" cy="365760"/>
           </a:xfrm>
           <a:prstGeom prst="rect">
             <a:avLst/>
@@ -6166,28 +6115,28 @@
           <a:lstStyle/>
           <a:p>
             <a:pPr algn="l">
-              <a:defRPr sz="1500" b="1">
-                <a:solidFill>
-                  <a:srgbClr val="2E7D32"/>
-                </a:solidFill>
-              </a:defRPr>
-            </a:pPr>
-            <a:r>
-              <a:t>On-Time: 97%</a:t>
-            </a:r>
-          </a:p>
-        </p:txBody>
-      </p:sp>
-      <p:sp>
-        <p:nvSpPr>
-          <p:cNvPr id="12" name="TextBox 11"/>
+              <a:defRPr sz="1400" b="1">
+                <a:solidFill>
+                  <a:srgbClr val="11273F"/>
+                </a:solidFill>
+              </a:defRPr>
+            </a:pPr>
+            <a:r>
+              <a:t>On-Time Delivery: 97%</a:t>
+            </a:r>
+          </a:p>
+        </p:txBody>
+      </p:sp>
+      <p:sp>
+        <p:nvSpPr>
+          <p:cNvPr id="11" name="TextBox 10"/>
           <p:cNvSpPr txBox="1"/>
           <p:nvPr/>
         </p:nvSpPr>
         <p:spPr>
           <a:xfrm>
-            <a:off x="6675120" y="2194560"/>
-            <a:ext cx="4754880" cy="457200"/>
+            <a:off x="1005840" y="3017520"/>
+            <a:ext cx="9144000" cy="365760"/>
           </a:xfrm>
           <a:prstGeom prst="rect">
             <a:avLst/>
@@ -6203,37 +6152,35 @@
             <a:pPr algn="l">
               <a:defRPr sz="1200" b="0">
                 <a:solidFill>
-                  <a:srgbClr val="FFFFFF"/>
-                </a:solidFill>
-              </a:defRPr>
-            </a:pPr>
-            <a:r>
-              <a:t>Quality: 99.5% | Risk: 2.0</a:t>
-            </a:r>
-          </a:p>
-        </p:txBody>
-      </p:sp>
-      <p:sp>
-        <p:nvSpPr>
-          <p:cNvPr id="13" name="Rounded Rectangle 12"/>
+                  <a:srgbClr val="6B7B8D"/>
+                </a:solidFill>
+              </a:defRPr>
+            </a:pPr>
+            <a:r>
+              <a:t>Quality pass rate: 99.5%  |  Risk score: 2.0/10</a:t>
+            </a:r>
+          </a:p>
+        </p:txBody>
+      </p:sp>
+      <p:sp>
+        <p:nvSpPr>
+          <p:cNvPr id="12" name="Rounded Rectangle 11"/>
           <p:cNvSpPr/>
           <p:nvPr/>
         </p:nvSpPr>
         <p:spPr>
           <a:xfrm>
-            <a:off x="731520" y="3200400"/>
-            <a:ext cx="5303520" cy="1371600"/>
+            <a:off x="731520" y="3566160"/>
+            <a:ext cx="10515600" cy="868680"/>
           </a:xfrm>
           <a:prstGeom prst="roundRect">
             <a:avLst/>
           </a:prstGeom>
           <a:solidFill>
-            <a:srgbClr val="0A1E38"/>
+            <a:srgbClr val="FFFFFF"/>
           </a:solidFill>
-          <a:ln w="25400">
-            <a:solidFill>
-              <a:srgbClr val="29B5E8"/>
-            </a:solidFill>
+          <a:ln>
+            <a:noFill/>
           </a:ln>
         </p:spPr>
         <p:style>
@@ -6260,14 +6207,14 @@
       </p:sp>
       <p:sp>
         <p:nvSpPr>
-          <p:cNvPr id="14" name="TextBox 13"/>
+          <p:cNvPr id="13" name="TextBox 12"/>
           <p:cNvSpPr txBox="1"/>
           <p:nvPr/>
         </p:nvSpPr>
         <p:spPr>
           <a:xfrm>
-            <a:off x="1005840" y="3291839"/>
-            <a:ext cx="4754880" cy="457200"/>
+            <a:off x="1005840" y="3657600"/>
+            <a:ext cx="4572000" cy="365760"/>
           </a:xfrm>
           <a:prstGeom prst="rect">
             <a:avLst/>
@@ -6281,28 +6228,28 @@
           <a:lstStyle/>
           <a:p>
             <a:pPr algn="l">
-              <a:defRPr sz="1500" b="1">
-                <a:solidFill>
-                  <a:srgbClr val="29B5E8"/>
-                </a:solidFill>
-              </a:defRPr>
-            </a:pPr>
-            <a:r>
-              <a:t>Open POs: On Schedule</a:t>
-            </a:r>
-          </a:p>
-        </p:txBody>
-      </p:sp>
-      <p:sp>
-        <p:nvSpPr>
-          <p:cNvPr id="15" name="TextBox 14"/>
+              <a:defRPr sz="1400" b="1">
+                <a:solidFill>
+                  <a:srgbClr val="11273F"/>
+                </a:solidFill>
+              </a:defRPr>
+            </a:pPr>
+            <a:r>
+              <a:t>Open POs: All On Schedule</a:t>
+            </a:r>
+          </a:p>
+        </p:txBody>
+      </p:sp>
+      <p:sp>
+        <p:nvSpPr>
+          <p:cNvPr id="14" name="TextBox 13"/>
           <p:cNvSpPr txBox="1"/>
           <p:nvPr/>
         </p:nvSpPr>
         <p:spPr>
           <a:xfrm>
-            <a:off x="1005840" y="3749039"/>
-            <a:ext cx="4754880" cy="457200"/>
+            <a:off x="1005840" y="4023360"/>
+            <a:ext cx="9144000" cy="365760"/>
           </a:xfrm>
           <a:prstGeom prst="rect">
             <a:avLst/>
@@ -6318,37 +6265,35 @@
             <a:pPr algn="l">
               <a:defRPr sz="1200" b="0">
                 <a:solidFill>
-                  <a:srgbClr val="FFFFFF"/>
-                </a:solidFill>
-              </a:defRPr>
-            </a:pPr>
-            <a:r>
-              <a:t>All delivery dates confirmed</a:t>
-            </a:r>
-          </a:p>
-        </p:txBody>
-      </p:sp>
-      <p:sp>
-        <p:nvSpPr>
-          <p:cNvPr id="16" name="Rounded Rectangle 15"/>
+                  <a:srgbClr val="6B7B8D"/>
+                </a:solidFill>
+              </a:defRPr>
+            </a:pPr>
+            <a:r>
+              <a:t>Expected delivery dates confirmed, no TMS flags</a:t>
+            </a:r>
+          </a:p>
+        </p:txBody>
+      </p:sp>
+      <p:sp>
+        <p:nvSpPr>
+          <p:cNvPr id="15" name="Rounded Rectangle 14"/>
           <p:cNvSpPr/>
           <p:nvPr/>
         </p:nvSpPr>
         <p:spPr>
           <a:xfrm>
-            <a:off x="6400800" y="3200400"/>
-            <a:ext cx="5303520" cy="1371600"/>
+            <a:off x="731520" y="4572000"/>
+            <a:ext cx="10515600" cy="868680"/>
           </a:xfrm>
           <a:prstGeom prst="roundRect">
             <a:avLst/>
           </a:prstGeom>
           <a:solidFill>
-            <a:srgbClr val="0A1E38"/>
+            <a:srgbClr val="F0F7FF"/>
           </a:solidFill>
-          <a:ln w="25400">
-            <a:solidFill>
-              <a:srgbClr val="2E7D32"/>
-            </a:solidFill>
+          <a:ln>
+            <a:noFill/>
           </a:ln>
         </p:spPr>
         <p:style>
@@ -6375,14 +6320,14 @@
       </p:sp>
       <p:sp>
         <p:nvSpPr>
-          <p:cNvPr id="17" name="TextBox 16"/>
+          <p:cNvPr id="16" name="TextBox 15"/>
           <p:cNvSpPr txBox="1"/>
           <p:nvPr/>
         </p:nvSpPr>
         <p:spPr>
           <a:xfrm>
-            <a:off x="6675120" y="3291839"/>
-            <a:ext cx="4754880" cy="457200"/>
+            <a:off x="1005840" y="4663440"/>
+            <a:ext cx="4572000" cy="365760"/>
           </a:xfrm>
           <a:prstGeom prst="rect">
             <a:avLst/>
@@ -6396,28 +6341,28 @@
           <a:lstStyle/>
           <a:p>
             <a:pPr algn="l">
-              <a:defRPr sz="1500" b="1">
-                <a:solidFill>
-                  <a:srgbClr val="2E7D32"/>
-                </a:solidFill>
-              </a:defRPr>
-            </a:pPr>
-            <a:r>
-              <a:t>Inventory: 18 Days</a:t>
-            </a:r>
-          </a:p>
-        </p:txBody>
-      </p:sp>
-      <p:sp>
-        <p:nvSpPr>
-          <p:cNvPr id="18" name="TextBox 17"/>
+              <a:defRPr sz="1400" b="1">
+                <a:solidFill>
+                  <a:srgbClr val="11273F"/>
+                </a:solidFill>
+              </a:defRPr>
+            </a:pPr>
+            <a:r>
+              <a:t>Alabama Glass Inventory: 18 Days</a:t>
+            </a:r>
+          </a:p>
+        </p:txBody>
+      </p:sp>
+      <p:sp>
+        <p:nvSpPr>
+          <p:cNvPr id="17" name="TextBox 16"/>
           <p:cNvSpPr txBox="1"/>
           <p:nvPr/>
         </p:nvSpPr>
         <p:spPr>
           <a:xfrm>
-            <a:off x="6675120" y="3749039"/>
-            <a:ext cx="4754880" cy="457200"/>
+            <a:off x="1005840" y="5029200"/>
+            <a:ext cx="9144000" cy="365760"/>
           </a:xfrm>
           <a:prstGeom prst="rect">
             <a:avLst/>
@@ -6433,26 +6378,26 @@
             <a:pPr algn="l">
               <a:defRPr sz="1200" b="0">
                 <a:solidFill>
-                  <a:srgbClr val="FFFFFF"/>
-                </a:solidFill>
-              </a:defRPr>
-            </a:pPr>
-            <a:r>
-              <a:t>Alabama forward coverage</a:t>
-            </a:r>
-          </a:p>
-        </p:txBody>
-      </p:sp>
-      <p:sp>
-        <p:nvSpPr>
-          <p:cNvPr id="19" name="Rounded Rectangle 18"/>
+                  <a:srgbClr val="6B7B8D"/>
+                </a:solidFill>
+              </a:defRPr>
+            </a:pPr>
+            <a:r>
+              <a:t>Forward coverage above minimum threshold</a:t>
+            </a:r>
+          </a:p>
+        </p:txBody>
+      </p:sp>
+      <p:sp>
+        <p:nvSpPr>
+          <p:cNvPr id="18" name="Rounded Rectangle 17"/>
           <p:cNvSpPr/>
           <p:nvPr/>
         </p:nvSpPr>
         <p:spPr>
           <a:xfrm>
-            <a:off x="731520" y="4846320"/>
-            <a:ext cx="10515600" cy="914400"/>
+            <a:off x="731520" y="5120640"/>
+            <a:ext cx="10515600" cy="822960"/>
           </a:xfrm>
           <a:prstGeom prst="roundRect">
             <a:avLst/>
@@ -6488,14 +6433,14 @@
       </p:sp>
       <p:sp>
         <p:nvSpPr>
-          <p:cNvPr id="20" name="TextBox 19"/>
+          <p:cNvPr id="19" name="TextBox 18"/>
           <p:cNvSpPr txBox="1"/>
           <p:nvPr/>
         </p:nvSpPr>
         <p:spPr>
           <a:xfrm>
-            <a:off x="1188720" y="4937760"/>
-            <a:ext cx="9601200" cy="822960"/>
+            <a:off x="1188720" y="5212080"/>
+            <a:ext cx="9601200" cy="640080"/>
           </a:xfrm>
           <a:prstGeom prst="rect">
             <a:avLst/>
@@ -6523,14 +6468,14 @@
       </p:sp>
       <p:sp>
         <p:nvSpPr>
-          <p:cNvPr id="21" name="TextBox 20"/>
+          <p:cNvPr id="20" name="TextBox 19"/>
           <p:cNvSpPr txBox="1"/>
           <p:nvPr/>
         </p:nvSpPr>
         <p:spPr>
           <a:xfrm>
-            <a:off x="731520" y="5943600"/>
-            <a:ext cx="10058400" cy="457200"/>
+            <a:off x="731520" y="6126480"/>
+            <a:ext cx="10058400" cy="365760"/>
           </a:xfrm>
           <a:prstGeom prst="rect">
             <a:avLst/>
@@ -6551,7 +6496,7 @@
               </a:defRPr>
             </a:pPr>
             <a:r>
-              <a:t>Oracle is RIGHT here. Data boundary, not failure.</a:t>
+              <a:t>DIRECTOR: Oracle is RIGHT here. Data boundary, not failure.</a:t>
             </a:r>
           </a:p>
         </p:txBody>
@@ -6570,7 +6515,7 @@
     <p:bg>
       <p:bgPr>
         <a:solidFill>
-          <a:srgbClr val="05142B"/>
+          <a:srgbClr val="F8FAFC"/>
         </a:solidFill>
         <a:effectLst/>
       </p:bgPr>
@@ -6584,7 +6529,7 @@
       <p:grpSpPr/>
       <p:pic>
         <p:nvPicPr>
-          <p:cNvPr id="2" name="Picture 1" descr="snowflake_logo_white.png"/>
+          <p:cNvPr id="2" name="Picture 1" descr="sf_logo_combined.png"/>
           <p:cNvPicPr>
             <a:picLocks noChangeAspect="1"/>
           </p:cNvPicPr>
@@ -6598,8 +6543,8 @@
         </p:blipFill>
         <p:spPr>
           <a:xfrm>
-            <a:off x="457200" y="274320"/>
-            <a:ext cx="457200" cy="457200"/>
+            <a:off x="365760" y="228600"/>
+            <a:ext cx="2468880" cy="411480"/>
           </a:xfrm>
           <a:prstGeom prst="rect">
             <a:avLst/>
@@ -6614,8 +6559,8 @@
         </p:nvSpPr>
         <p:spPr>
           <a:xfrm>
-            <a:off x="457200" y="6446520"/>
-            <a:ext cx="11247120" cy="27432"/>
+            <a:off x="0" y="6583680"/>
+            <a:ext cx="12191695" cy="36576"/>
           </a:xfrm>
           <a:prstGeom prst="rect">
             <a:avLst/>
@@ -6657,8 +6602,8 @@
         </p:nvSpPr>
         <p:spPr>
           <a:xfrm>
-            <a:off x="731520" y="731520"/>
-            <a:ext cx="1645920" cy="548640"/>
+            <a:off x="731520" y="777240"/>
+            <a:ext cx="1463040" cy="457200"/>
           </a:xfrm>
           <a:prstGeom prst="roundRect">
             <a:avLst/>
@@ -6689,7 +6634,7 @@
           <a:lstStyle/>
           <a:p>
             <a:pPr algn="ctr">
-              <a:defRPr sz="1600" b="1">
+              <a:defRPr sz="1300" b="1">
                 <a:solidFill>
                   <a:srgbClr val="FFFFFF"/>
                 </a:solidFill>
@@ -6709,8 +6654,8 @@
         </p:nvSpPr>
         <p:spPr>
           <a:xfrm>
-            <a:off x="2560320" y="731520"/>
-            <a:ext cx="8229600" cy="548640"/>
+            <a:off x="2377440" y="777240"/>
+            <a:ext cx="8229600" cy="457200"/>
           </a:xfrm>
           <a:prstGeom prst="rect">
             <a:avLst/>
@@ -6724,9 +6669,9 @@
           <a:lstStyle/>
           <a:p>
             <a:pPr algn="l">
-              <a:defRPr sz="2400" b="1">
-                <a:solidFill>
-                  <a:srgbClr val="FFFFFF"/>
+              <a:defRPr sz="2200" b="1">
+                <a:solidFill>
+                  <a:srgbClr val="11273F"/>
                 </a:solidFill>
               </a:defRPr>
             </a:pPr>
@@ -6736,39 +6681,15 @@
           </a:p>
         </p:txBody>
       </p:sp>
-      <p:pic>
-        <p:nvPicPr>
-          <p:cNvPr id="6" name="Picture 5" descr="icon_mfg.png"/>
-          <p:cNvPicPr>
-            <a:picLocks noChangeAspect="1"/>
-          </p:cNvPicPr>
-          <p:nvPr/>
-        </p:nvPicPr>
-        <p:blipFill>
-          <a:blip r:embed="rId3"/>
-          <a:stretch>
-            <a:fillRect/>
-          </a:stretch>
-        </p:blipFill>
-        <p:spPr>
-          <a:xfrm>
-            <a:off x="10515600" y="640080"/>
-            <a:ext cx="731520" cy="731520"/>
-          </a:xfrm>
-          <a:prstGeom prst="rect">
-            <a:avLst/>
-          </a:prstGeom>
-        </p:spPr>
-      </p:pic>
-      <p:sp>
-        <p:nvSpPr>
-          <p:cNvPr id="7" name="TextBox 6"/>
+      <p:sp>
+        <p:nvSpPr>
+          <p:cNvPr id="6" name="TextBox 5"/>
           <p:cNvSpPr txBox="1"/>
           <p:nvPr/>
         </p:nvSpPr>
         <p:spPr>
           <a:xfrm>
-            <a:off x="1097280" y="1645920"/>
+            <a:off x="1097280" y="1554480"/>
             <a:ext cx="9144000" cy="457200"/>
           </a:xfrm>
           <a:prstGeom prst="rect">
@@ -6785,25 +6706,25 @@
             <a:pPr algn="l">
               <a:defRPr sz="1400" b="0">
                 <a:solidFill>
-                  <a:srgbClr val="FFFFFF"/>
-                </a:solidFill>
-              </a:defRPr>
-            </a:pPr>
-            <a:r>
-              <a:t>Daily consumption: 530 panels/day at Alabama</a:t>
-            </a:r>
-          </a:p>
-        </p:txBody>
-      </p:sp>
-      <p:sp>
-        <p:nvSpPr>
-          <p:cNvPr id="8" name="TextBox 7"/>
+                  <a:srgbClr val="333333"/>
+                </a:solidFill>
+              </a:defRPr>
+            </a:pPr>
+            <a:r>
+              <a:t>Daily glass consumption: ~530 panels/day at Alabama</a:t>
+            </a:r>
+          </a:p>
+        </p:txBody>
+      </p:sp>
+      <p:sp>
+        <p:nvSpPr>
+          <p:cNvPr id="7" name="TextBox 6"/>
           <p:cNvSpPr txBox="1"/>
           <p:nvPr/>
         </p:nvSpPr>
         <p:spPr>
           <a:xfrm>
-            <a:off x="1097280" y="2286000"/>
+            <a:off x="1097280" y="2194560"/>
             <a:ext cx="9144000" cy="457200"/>
           </a:xfrm>
           <a:prstGeom prst="rect">
@@ -6820,25 +6741,25 @@
             <a:pPr algn="l">
               <a:defRPr sz="1400" b="0">
                 <a:solidFill>
-                  <a:srgbClr val="FFFFFF"/>
-                </a:solidFill>
-              </a:defRPr>
-            </a:pPr>
-            <a:r>
-              <a:t>Series 7 ramping — NextEra, Invenergy Q2 commitments</a:t>
-            </a:r>
-          </a:p>
-        </p:txBody>
-      </p:sp>
-      <p:sp>
-        <p:nvSpPr>
-          <p:cNvPr id="9" name="TextBox 8"/>
+                  <a:srgbClr val="333333"/>
+                </a:solidFill>
+              </a:defRPr>
+            </a:pPr>
+            <a:r>
+              <a:t>Series 7 ramping for Q2 — NextEra, Invenergy commitments</a:t>
+            </a:r>
+          </a:p>
+        </p:txBody>
+      </p:sp>
+      <p:sp>
+        <p:nvSpPr>
+          <p:cNvPr id="8" name="TextBox 7"/>
           <p:cNvSpPr txBox="1"/>
           <p:nvPr/>
         </p:nvSpPr>
         <p:spPr>
           <a:xfrm>
-            <a:off x="1097280" y="2926080"/>
+            <a:off x="1097280" y="2834639"/>
             <a:ext cx="9144000" cy="457200"/>
           </a:xfrm>
           <a:prstGeom prst="rect">
@@ -6855,25 +6776,25 @@
             <a:pPr algn="l">
               <a:defRPr sz="1400" b="0">
                 <a:solidFill>
-                  <a:srgbClr val="FFFFFF"/>
-                </a:solidFill>
-              </a:defRPr>
-            </a:pPr>
-            <a:r>
-              <a:t>BOM: 1 glass/module, NO substitute exists</a:t>
-            </a:r>
-          </a:p>
-        </p:txBody>
-      </p:sp>
-      <p:sp>
-        <p:nvSpPr>
-          <p:cNvPr id="10" name="TextBox 9"/>
+                  <a:srgbClr val="333333"/>
+                </a:solidFill>
+              </a:defRPr>
+            </a:pPr>
+            <a:r>
+              <a:t>BOM constraint: 1 substrate glass per module, NO substitute</a:t>
+            </a:r>
+          </a:p>
+        </p:txBody>
+      </p:sp>
+      <p:sp>
+        <p:nvSpPr>
+          <p:cNvPr id="9" name="TextBox 8"/>
           <p:cNvSpPr txBox="1"/>
           <p:nvPr/>
         </p:nvSpPr>
         <p:spPr>
           <a:xfrm>
-            <a:off x="1097280" y="3566159"/>
+            <a:off x="1097280" y="3474720"/>
             <a:ext cx="9144000" cy="457200"/>
           </a:xfrm>
           <a:prstGeom prst="rect">
@@ -6890,25 +6811,25 @@
             <a:pPr algn="l">
               <a:defRPr sz="1400" b="0">
                 <a:solidFill>
-                  <a:srgbClr val="FFFFFF"/>
-                </a:solidFill>
-              </a:defRPr>
-            </a:pPr>
-            <a:r>
-              <a:t>18 days coverage = zero buffer for disruption</a:t>
-            </a:r>
-          </a:p>
-        </p:txBody>
-      </p:sp>
-      <p:sp>
-        <p:nvSpPr>
-          <p:cNvPr id="11" name="TextBox 10"/>
+                  <a:srgbClr val="333333"/>
+                </a:solidFill>
+              </a:defRPr>
+            </a:pPr>
+            <a:r>
+              <a:t>18 days coverage at burn rate = zero buffer for disruption</a:t>
+            </a:r>
+          </a:p>
+        </p:txBody>
+      </p:sp>
+      <p:sp>
+        <p:nvSpPr>
+          <p:cNvPr id="10" name="TextBox 9"/>
           <p:cNvSpPr txBox="1"/>
           <p:nvPr/>
         </p:nvSpPr>
         <p:spPr>
           <a:xfrm>
-            <a:off x="1097280" y="4206240"/>
+            <a:off x="1097280" y="4114800"/>
             <a:ext cx="9144000" cy="457200"/>
           </a:xfrm>
           <a:prstGeom prst="rect">
@@ -6925,26 +6846,26 @@
             <a:pPr algn="l">
               <a:defRPr sz="1400" b="0">
                 <a:solidFill>
-                  <a:srgbClr val="FFFFFF"/>
-                </a:solidFill>
-              </a:defRPr>
-            </a:pPr>
-            <a:r>
-              <a:t>Deliveries MUST arrive on time to maintain plan</a:t>
-            </a:r>
-          </a:p>
-        </p:txBody>
-      </p:sp>
-      <p:sp>
-        <p:nvSpPr>
-          <p:cNvPr id="12" name="Rounded Rectangle 11"/>
+                  <a:srgbClr val="333333"/>
+                </a:solidFill>
+              </a:defRPr>
+            </a:pPr>
+            <a:r>
+              <a:t>Deliveries MUST arrive on time to maintain production plan</a:t>
+            </a:r>
+          </a:p>
+        </p:txBody>
+      </p:sp>
+      <p:sp>
+        <p:nvSpPr>
+          <p:cNvPr id="11" name="Rounded Rectangle 10"/>
           <p:cNvSpPr/>
           <p:nvPr/>
         </p:nvSpPr>
         <p:spPr>
           <a:xfrm>
-            <a:off x="731520" y="5029200"/>
-            <a:ext cx="10515600" cy="914400"/>
+            <a:off x="731520" y="4937760"/>
+            <a:ext cx="10515600" cy="822960"/>
           </a:xfrm>
           <a:prstGeom prst="roundRect">
             <a:avLst/>
@@ -6980,14 +6901,14 @@
       </p:sp>
       <p:sp>
         <p:nvSpPr>
-          <p:cNvPr id="13" name="TextBox 12"/>
+          <p:cNvPr id="12" name="TextBox 11"/>
           <p:cNvSpPr txBox="1"/>
           <p:nvPr/>
         </p:nvSpPr>
         <p:spPr>
           <a:xfrm>
-            <a:off x="1188720" y="5120640"/>
-            <a:ext cx="9601200" cy="822960"/>
+            <a:off x="1188720" y="5029200"/>
+            <a:ext cx="9601200" cy="640080"/>
           </a:xfrm>
           <a:prstGeom prst="rect">
             <a:avLst/>
@@ -7015,13 +6936,13 @@
       </p:sp>
       <p:sp>
         <p:nvSpPr>
-          <p:cNvPr id="14" name="TextBox 13"/>
+          <p:cNvPr id="13" name="TextBox 12"/>
           <p:cNvSpPr txBox="1"/>
           <p:nvPr/>
         </p:nvSpPr>
         <p:spPr>
           <a:xfrm>
-            <a:off x="731520" y="6126480"/>
+            <a:off x="731520" y="5943600"/>
             <a:ext cx="10058400" cy="365760"/>
           </a:xfrm>
           <a:prstGeom prst="rect">
@@ -7043,7 +6964,7 @@
               </a:defRPr>
             </a:pPr>
             <a:r>
-              <a:t>Sets up WHY external layer is the unlock.</a:t>
+              <a:t>Sets up WHY the external layer is the unlock.</a:t>
             </a:r>
           </a:p>
         </p:txBody>
@@ -7062,7 +6983,7 @@
     <p:bg>
       <p:bgPr>
         <a:solidFill>
-          <a:srgbClr val="05142B"/>
+          <a:srgbClr val="11273F"/>
         </a:solidFill>
         <a:effectLst/>
       </p:bgPr>
@@ -7076,7 +6997,7 @@
       <p:grpSpPr/>
       <p:pic>
         <p:nvPicPr>
-          <p:cNvPr id="2" name="Picture 1" descr="snowflake_logo_white.png"/>
+          <p:cNvPr id="2" name="Picture 1" descr="sf_logo_combined.png"/>
           <p:cNvPicPr>
             <a:picLocks noChangeAspect="1"/>
           </p:cNvPicPr>
@@ -7090,8 +7011,8 @@
         </p:blipFill>
         <p:spPr>
           <a:xfrm>
-            <a:off x="457200" y="274320"/>
-            <a:ext cx="457200" cy="457200"/>
+            <a:off x="365760" y="228600"/>
+            <a:ext cx="2468880" cy="411480"/>
           </a:xfrm>
           <a:prstGeom prst="rect">
             <a:avLst/>
@@ -7106,8 +7027,8 @@
         </p:nvSpPr>
         <p:spPr>
           <a:xfrm>
-            <a:off x="457200" y="6446520"/>
-            <a:ext cx="11247120" cy="27432"/>
+            <a:off x="0" y="6583680"/>
+            <a:ext cx="12191695" cy="36576"/>
           </a:xfrm>
           <a:prstGeom prst="rect">
             <a:avLst/>
@@ -7149,8 +7070,8 @@
         </p:nvSpPr>
         <p:spPr>
           <a:xfrm>
-            <a:off x="731520" y="640080"/>
-            <a:ext cx="1645920" cy="548640"/>
+            <a:off x="731520" y="731520"/>
+            <a:ext cx="1463040" cy="457200"/>
           </a:xfrm>
           <a:prstGeom prst="roundRect">
             <a:avLst/>
@@ -7181,7 +7102,7 @@
           <a:lstStyle/>
           <a:p>
             <a:pPr algn="ctr">
-              <a:defRPr sz="1600" b="1">
+              <a:defRPr sz="1300" b="1">
                 <a:solidFill>
                   <a:srgbClr val="FFFFFF"/>
                 </a:solidFill>
@@ -7201,8 +7122,8 @@
         </p:nvSpPr>
         <p:spPr>
           <a:xfrm>
-            <a:off x="2560320" y="640080"/>
-            <a:ext cx="8229600" cy="548640"/>
+            <a:off x="2377440" y="731520"/>
+            <a:ext cx="8229600" cy="457200"/>
           </a:xfrm>
           <a:prstGeom prst="rect">
             <a:avLst/>
@@ -7216,52 +7137,28 @@
           <a:lstStyle/>
           <a:p>
             <a:pPr algn="l">
-              <a:defRPr sz="2400" b="1">
+              <a:defRPr sz="2200" b="1">
                 <a:solidFill>
                   <a:srgbClr val="E65100"/>
                 </a:solidFill>
               </a:defRPr>
             </a:pPr>
             <a:r>
-              <a:t>External Signal — THE REVEAL</a:t>
-            </a:r>
-          </a:p>
-        </p:txBody>
-      </p:sp>
-      <p:pic>
-        <p:nvPicPr>
-          <p:cNvPr id="6" name="Picture 5" descr="icon_external.png"/>
-          <p:cNvPicPr>
-            <a:picLocks noChangeAspect="1"/>
-          </p:cNvPicPr>
-          <p:nvPr/>
-        </p:nvPicPr>
-        <p:blipFill>
-          <a:blip r:embed="rId3"/>
-          <a:stretch>
-            <a:fillRect/>
-          </a:stretch>
-        </p:blipFill>
-        <p:spPr>
-          <a:xfrm>
-            <a:off x="10515600" y="548640"/>
-            <a:ext cx="731520" cy="731520"/>
-          </a:xfrm>
-          <a:prstGeom prst="rect">
-            <a:avLst/>
-          </a:prstGeom>
-        </p:spPr>
-      </p:pic>
-      <p:sp>
-        <p:nvSpPr>
-          <p:cNvPr id="7" name="TextBox 6"/>
+              <a:t>External Marketplace Signal — THE REVEAL</a:t>
+            </a:r>
+          </a:p>
+        </p:txBody>
+      </p:sp>
+      <p:sp>
+        <p:nvSpPr>
+          <p:cNvPr id="6" name="TextBox 5"/>
           <p:cNvSpPr txBox="1"/>
           <p:nvPr/>
         </p:nvSpPr>
         <p:spPr>
           <a:xfrm>
-            <a:off x="731520" y="1280160"/>
-            <a:ext cx="10058400" cy="365760"/>
+            <a:off x="731520" y="1371600"/>
+            <a:ext cx="10058400" cy="274320"/>
           </a:xfrm>
           <a:prstGeom prst="rect">
             <a:avLst/>
@@ -7275,39 +7172,37 @@
           <a:lstStyle/>
           <a:p>
             <a:pPr algn="l">
-              <a:defRPr sz="1300" b="0">
-                <a:solidFill>
-                  <a:srgbClr val="8E9EAB"/>
-                </a:solidFill>
-              </a:defRPr>
-            </a:pPr>
-            <a:r>
-              <a:t>Snowflake Marketplace trade/shipping data:</a:t>
-            </a:r>
-          </a:p>
-        </p:txBody>
-      </p:sp>
-      <p:sp>
-        <p:nvSpPr>
-          <p:cNvPr id="8" name="Rounded Rectangle 7"/>
+              <a:defRPr sz="1200" b="0">
+                <a:solidFill>
+                  <a:srgbClr val="6B7B8D"/>
+                </a:solidFill>
+              </a:defRPr>
+            </a:pPr>
+            <a:r>
+              <a:t>Snowflake Marketplace trade/shipping data surfaces lane deterioration:</a:t>
+            </a:r>
+          </a:p>
+        </p:txBody>
+      </p:sp>
+      <p:sp>
+        <p:nvSpPr>
+          <p:cNvPr id="7" name="Rounded Rectangle 6"/>
           <p:cNvSpPr/>
           <p:nvPr/>
         </p:nvSpPr>
         <p:spPr>
           <a:xfrm>
-            <a:off x="731520" y="1828800"/>
+            <a:off x="731520" y="1737360"/>
             <a:ext cx="2560320" cy="1371600"/>
           </a:xfrm>
           <a:prstGeom prst="roundRect">
             <a:avLst/>
           </a:prstGeom>
           <a:solidFill>
-            <a:srgbClr val="0A1E38"/>
+            <a:srgbClr val="1A2E45"/>
           </a:solidFill>
-          <a:ln w="25400">
-            <a:solidFill>
-              <a:srgbClr val="C62828"/>
-            </a:solidFill>
+          <a:ln>
+            <a:noFill/>
           </a:ln>
         </p:spPr>
         <p:style>
@@ -7334,13 +7229,13 @@
       </p:sp>
       <p:sp>
         <p:nvSpPr>
-          <p:cNvPr id="9" name="TextBox 8"/>
+          <p:cNvPr id="8" name="TextBox 7"/>
           <p:cNvSpPr txBox="1"/>
           <p:nvPr/>
         </p:nvSpPr>
         <p:spPr>
           <a:xfrm>
-            <a:off x="914400" y="1920240"/>
+            <a:off x="914400" y="1828800"/>
             <a:ext cx="2194560" cy="274320"/>
           </a:xfrm>
           <a:prstGeom prst="rect">
@@ -7357,7 +7252,7 @@
             <a:pPr algn="ctr">
               <a:defRPr sz="1000" b="0">
                 <a:solidFill>
-                  <a:srgbClr val="8E9EAB"/>
+                  <a:srgbClr val="6B7B8D"/>
                 </a:solidFill>
               </a:defRPr>
             </a:pPr>
@@ -7369,14 +7264,14 @@
       </p:sp>
       <p:sp>
         <p:nvSpPr>
-          <p:cNvPr id="10" name="TextBox 9"/>
+          <p:cNvPr id="9" name="TextBox 8"/>
           <p:cNvSpPr txBox="1"/>
           <p:nvPr/>
         </p:nvSpPr>
         <p:spPr>
           <a:xfrm>
-            <a:off x="914400" y="2286000"/>
-            <a:ext cx="2194560" cy="548640"/>
+            <a:off x="914400" y="2103120"/>
+            <a:ext cx="2194560" cy="640080"/>
           </a:xfrm>
           <a:prstGeom prst="rect">
             <a:avLst/>
@@ -7390,7 +7285,7 @@
           <a:lstStyle/>
           <a:p>
             <a:pPr algn="ctr">
-              <a:defRPr sz="2000" b="1">
+              <a:defRPr sz="2200" b="1">
                 <a:solidFill>
                   <a:srgbClr val="C62828"/>
                 </a:solidFill>
@@ -7404,13 +7299,13 @@
       </p:sp>
       <p:sp>
         <p:nvSpPr>
-          <p:cNvPr id="11" name="TextBox 10"/>
+          <p:cNvPr id="10" name="TextBox 9"/>
           <p:cNvSpPr txBox="1"/>
           <p:nvPr/>
         </p:nvSpPr>
         <p:spPr>
           <a:xfrm>
-            <a:off x="914400" y="2834640"/>
+            <a:off x="914400" y="2743200"/>
             <a:ext cx="2194560" cy="274320"/>
           </a:xfrm>
           <a:prstGeom prst="rect">
@@ -7439,25 +7334,23 @@
       </p:sp>
       <p:sp>
         <p:nvSpPr>
-          <p:cNvPr id="12" name="Rounded Rectangle 11"/>
+          <p:cNvPr id="11" name="Rounded Rectangle 10"/>
           <p:cNvSpPr/>
           <p:nvPr/>
         </p:nvSpPr>
         <p:spPr>
           <a:xfrm>
-            <a:off x="3566160" y="1828800"/>
+            <a:off x="3566160" y="1737360"/>
             <a:ext cx="2560320" cy="1371600"/>
           </a:xfrm>
           <a:prstGeom prst="roundRect">
             <a:avLst/>
           </a:prstGeom>
           <a:solidFill>
-            <a:srgbClr val="0A1E38"/>
+            <a:srgbClr val="1A2E45"/>
           </a:solidFill>
-          <a:ln w="25400">
-            <a:solidFill>
-              <a:srgbClr val="C62828"/>
-            </a:solidFill>
+          <a:ln>
+            <a:noFill/>
           </a:ln>
         </p:spPr>
         <p:style>
@@ -7484,13 +7377,13 @@
       </p:sp>
       <p:sp>
         <p:nvSpPr>
-          <p:cNvPr id="13" name="TextBox 12"/>
+          <p:cNvPr id="12" name="TextBox 11"/>
           <p:cNvSpPr txBox="1"/>
           <p:nvPr/>
         </p:nvSpPr>
         <p:spPr>
           <a:xfrm>
-            <a:off x="3749040" y="1920240"/>
+            <a:off x="3749040" y="1828800"/>
             <a:ext cx="2194560" cy="274320"/>
           </a:xfrm>
           <a:prstGeom prst="rect">
@@ -7507,7 +7400,7 @@
             <a:pPr algn="ctr">
               <a:defRPr sz="1000" b="0">
                 <a:solidFill>
-                  <a:srgbClr val="8E9EAB"/>
+                  <a:srgbClr val="6B7B8D"/>
                 </a:solidFill>
               </a:defRPr>
             </a:pPr>
@@ -7519,14 +7412,14 @@
       </p:sp>
       <p:sp>
         <p:nvSpPr>
-          <p:cNvPr id="14" name="TextBox 13"/>
+          <p:cNvPr id="13" name="TextBox 12"/>
           <p:cNvSpPr txBox="1"/>
           <p:nvPr/>
         </p:nvSpPr>
         <p:spPr>
           <a:xfrm>
-            <a:off x="3749040" y="2286000"/>
-            <a:ext cx="2194560" cy="548640"/>
+            <a:off x="3749040" y="2103120"/>
+            <a:ext cx="2194560" cy="640080"/>
           </a:xfrm>
           <a:prstGeom prst="rect">
             <a:avLst/>
@@ -7540,7 +7433,7 @@
           <a:lstStyle/>
           <a:p>
             <a:pPr algn="ctr">
-              <a:defRPr sz="2000" b="1">
+              <a:defRPr sz="2200" b="1">
                 <a:solidFill>
                   <a:srgbClr val="C62828"/>
                 </a:solidFill>
@@ -7554,13 +7447,13 @@
       </p:sp>
       <p:sp>
         <p:nvSpPr>
-          <p:cNvPr id="15" name="TextBox 14"/>
+          <p:cNvPr id="14" name="TextBox 13"/>
           <p:cNvSpPr txBox="1"/>
           <p:nvPr/>
         </p:nvSpPr>
         <p:spPr>
           <a:xfrm>
-            <a:off x="3749040" y="2834640"/>
+            <a:off x="3749040" y="2743200"/>
             <a:ext cx="2194560" cy="274320"/>
           </a:xfrm>
           <a:prstGeom prst="rect">
@@ -7582,32 +7475,30 @@
               </a:defRPr>
             </a:pPr>
             <a:r>
-              <a:t>25hr → 43hr</a:t>
-            </a:r>
-          </a:p>
-        </p:txBody>
-      </p:sp>
-      <p:sp>
-        <p:nvSpPr>
-          <p:cNvPr id="16" name="Rounded Rectangle 15"/>
+              <a:t>25h → 43h</a:t>
+            </a:r>
+          </a:p>
+        </p:txBody>
+      </p:sp>
+      <p:sp>
+        <p:nvSpPr>
+          <p:cNvPr id="15" name="Rounded Rectangle 14"/>
           <p:cNvSpPr/>
           <p:nvPr/>
         </p:nvSpPr>
         <p:spPr>
           <a:xfrm>
-            <a:off x="6400800" y="1828800"/>
+            <a:off x="6400800" y="1737360"/>
             <a:ext cx="2560320" cy="1371600"/>
           </a:xfrm>
           <a:prstGeom prst="roundRect">
             <a:avLst/>
           </a:prstGeom>
           <a:solidFill>
-            <a:srgbClr val="0A1E38"/>
+            <a:srgbClr val="1A2E45"/>
           </a:solidFill>
-          <a:ln w="25400">
-            <a:solidFill>
-              <a:srgbClr val="E65100"/>
-            </a:solidFill>
+          <a:ln>
+            <a:noFill/>
           </a:ln>
         </p:spPr>
         <p:style>
@@ -7634,13 +7525,13 @@
       </p:sp>
       <p:sp>
         <p:nvSpPr>
-          <p:cNvPr id="17" name="TextBox 16"/>
+          <p:cNvPr id="16" name="TextBox 15"/>
           <p:cNvSpPr txBox="1"/>
           <p:nvPr/>
         </p:nvSpPr>
         <p:spPr>
           <a:xfrm>
-            <a:off x="6583680" y="1920240"/>
+            <a:off x="6583680" y="1828800"/>
             <a:ext cx="2194560" cy="274320"/>
           </a:xfrm>
           <a:prstGeom prst="rect">
@@ -7657,7 +7548,7 @@
             <a:pPr algn="ctr">
               <a:defRPr sz="1000" b="0">
                 <a:solidFill>
-                  <a:srgbClr val="8E9EAB"/>
+                  <a:srgbClr val="6B7B8D"/>
                 </a:solidFill>
               </a:defRPr>
             </a:pPr>
@@ -7669,14 +7560,14 @@
       </p:sp>
       <p:sp>
         <p:nvSpPr>
-          <p:cNvPr id="18" name="TextBox 17"/>
+          <p:cNvPr id="17" name="TextBox 16"/>
           <p:cNvSpPr txBox="1"/>
           <p:nvPr/>
         </p:nvSpPr>
         <p:spPr>
           <a:xfrm>
-            <a:off x="6583680" y="2286000"/>
-            <a:ext cx="2194560" cy="548640"/>
+            <a:off x="6583680" y="2103120"/>
+            <a:ext cx="2194560" cy="640080"/>
           </a:xfrm>
           <a:prstGeom prst="rect">
             <a:avLst/>
@@ -7690,9 +7581,9 @@
           <a:lstStyle/>
           <a:p>
             <a:pPr algn="ctr">
-              <a:defRPr sz="2000" b="1">
-                <a:solidFill>
-                  <a:srgbClr val="E65100"/>
+              <a:defRPr sz="2200" b="1">
+                <a:solidFill>
+                  <a:srgbClr val="C62828"/>
                 </a:solidFill>
               </a:defRPr>
             </a:pPr>
@@ -7704,13 +7595,13 @@
       </p:sp>
       <p:sp>
         <p:nvSpPr>
-          <p:cNvPr id="19" name="TextBox 18"/>
+          <p:cNvPr id="18" name="TextBox 17"/>
           <p:cNvSpPr txBox="1"/>
           <p:nvPr/>
         </p:nvSpPr>
         <p:spPr>
           <a:xfrm>
-            <a:off x="6583680" y="2834640"/>
+            <a:off x="6583680" y="2743200"/>
             <a:ext cx="2194560" cy="274320"/>
           </a:xfrm>
           <a:prstGeom prst="rect">
@@ -7732,32 +7623,30 @@
               </a:defRPr>
             </a:pPr>
             <a:r>
-              <a:t>Emerging</a:t>
-            </a:r>
-          </a:p>
-        </p:txBody>
-      </p:sp>
-      <p:sp>
-        <p:nvSpPr>
-          <p:cNvPr id="20" name="Rounded Rectangle 19"/>
+              <a:t>Emerging risk</a:t>
+            </a:r>
+          </a:p>
+        </p:txBody>
+      </p:sp>
+      <p:sp>
+        <p:nvSpPr>
+          <p:cNvPr id="19" name="Rounded Rectangle 18"/>
           <p:cNvSpPr/>
           <p:nvPr/>
         </p:nvSpPr>
         <p:spPr>
           <a:xfrm>
-            <a:off x="9235440" y="1828800"/>
+            <a:off x="9235440" y="1737360"/>
             <a:ext cx="2560320" cy="1371600"/>
           </a:xfrm>
           <a:prstGeom prst="roundRect">
             <a:avLst/>
           </a:prstGeom>
           <a:solidFill>
-            <a:srgbClr val="0A1E38"/>
+            <a:srgbClr val="1A2E45"/>
           </a:solidFill>
-          <a:ln w="25400">
-            <a:solidFill>
-              <a:srgbClr val="E65100"/>
-            </a:solidFill>
+          <a:ln>
+            <a:noFill/>
           </a:ln>
         </p:spPr>
         <p:style>
@@ -7784,13 +7673,13 @@
       </p:sp>
       <p:sp>
         <p:nvSpPr>
-          <p:cNvPr id="21" name="TextBox 20"/>
+          <p:cNvPr id="20" name="TextBox 19"/>
           <p:cNvSpPr txBox="1"/>
           <p:nvPr/>
         </p:nvSpPr>
         <p:spPr>
           <a:xfrm>
-            <a:off x="9418320" y="1920240"/>
+            <a:off x="9418320" y="1828800"/>
             <a:ext cx="2194560" cy="274320"/>
           </a:xfrm>
           <a:prstGeom prst="rect">
@@ -7807,26 +7696,26 @@
             <a:pPr algn="ctr">
               <a:defRPr sz="1000" b="0">
                 <a:solidFill>
-                  <a:srgbClr val="8E9EAB"/>
-                </a:solidFill>
-              </a:defRPr>
-            </a:pPr>
-            <a:r>
-              <a:t>Transit</a:t>
-            </a:r>
-          </a:p>
-        </p:txBody>
-      </p:sp>
-      <p:sp>
-        <p:nvSpPr>
-          <p:cNvPr id="22" name="TextBox 21"/>
+                  <a:srgbClr val="6B7B8D"/>
+                </a:solidFill>
+              </a:defRPr>
+            </a:pPr>
+            <a:r>
+              <a:t>Transit Time</a:t>
+            </a:r>
+          </a:p>
+        </p:txBody>
+      </p:sp>
+      <p:sp>
+        <p:nvSpPr>
+          <p:cNvPr id="21" name="TextBox 20"/>
           <p:cNvSpPr txBox="1"/>
           <p:nvPr/>
         </p:nvSpPr>
         <p:spPr>
           <a:xfrm>
-            <a:off x="9418320" y="2286000"/>
-            <a:ext cx="2194560" cy="548640"/>
+            <a:off x="9418320" y="2103120"/>
+            <a:ext cx="2194560" cy="640080"/>
           </a:xfrm>
           <a:prstGeom prst="rect">
             <a:avLst/>
@@ -7840,9 +7729,9 @@
           <a:lstStyle/>
           <a:p>
             <a:pPr algn="ctr">
-              <a:defRPr sz="2000" b="1">
-                <a:solidFill>
-                  <a:srgbClr val="E65100"/>
+              <a:defRPr sz="2200" b="1">
+                <a:solidFill>
+                  <a:srgbClr val="C62828"/>
                 </a:solidFill>
               </a:defRPr>
             </a:pPr>
@@ -7854,13 +7743,13 @@
       </p:sp>
       <p:sp>
         <p:nvSpPr>
-          <p:cNvPr id="23" name="TextBox 22"/>
+          <p:cNvPr id="22" name="TextBox 21"/>
           <p:cNvSpPr txBox="1"/>
           <p:nvPr/>
         </p:nvSpPr>
         <p:spPr>
           <a:xfrm>
-            <a:off x="9418320" y="2834640"/>
+            <a:off x="9418320" y="2743200"/>
             <a:ext cx="2194560" cy="274320"/>
           </a:xfrm>
           <a:prstGeom prst="rect">
@@ -7889,14 +7778,14 @@
       </p:sp>
       <p:sp>
         <p:nvSpPr>
-          <p:cNvPr id="24" name="Rounded Rectangle 23"/>
+          <p:cNvPr id="23" name="Rounded Rectangle 22"/>
           <p:cNvSpPr/>
           <p:nvPr/>
         </p:nvSpPr>
         <p:spPr>
           <a:xfrm>
-            <a:off x="457200" y="3566160"/>
-            <a:ext cx="11247120" cy="1554480"/>
+            <a:off x="457200" y="3383280"/>
+            <a:ext cx="11247120" cy="1645920"/>
           </a:xfrm>
           <a:prstGeom prst="roundRect">
             <a:avLst/>
@@ -7932,14 +7821,14 @@
       </p:sp>
       <p:sp>
         <p:nvSpPr>
-          <p:cNvPr id="25" name="TextBox 24"/>
+          <p:cNvPr id="24" name="TextBox 23"/>
           <p:cNvSpPr txBox="1"/>
           <p:nvPr/>
         </p:nvSpPr>
         <p:spPr>
           <a:xfrm>
-            <a:off x="914400" y="3657600"/>
-            <a:ext cx="10515600" cy="1371600"/>
+            <a:off x="914400" y="3474720"/>
+            <a:ext cx="10515600" cy="1463040"/>
           </a:xfrm>
           <a:prstGeom prst="rect">
             <a:avLst/>
@@ -7953,7 +7842,7 @@
           <a:lstStyle/>
           <a:p>
             <a:pPr algn="l">
-              <a:defRPr sz="1400" b="1">
+              <a:defRPr sz="1300" b="1">
                 <a:solidFill>
                   <a:srgbClr val="FFFFFF"/>
                 </a:solidFill>
@@ -7964,10 +7853,14 @@
             </a:r>
             <a:br/>
             <a:r>
-              <a:t>Inventory: 18 days. External data shows deteriorating lane.</a:t>
+              <a:t>Inventory: 18 days. Oracle shows on-schedule, but external shipping data</a:t>
             </a:r>
             <a:br/>
             <a:r>
+              <a:t>indicates deteriorating activity on the ABC Glass lane.</a:t>
+            </a:r>
+            <a:br/>
+            <a:r>
               <a:t>A 2-week disruption puts ~134 MW of production at risk."</a:t>
             </a:r>
           </a:p>
@@ -7975,14 +7868,14 @@
       </p:sp>
       <p:sp>
         <p:nvSpPr>
-          <p:cNvPr id="26" name="TextBox 25"/>
+          <p:cNvPr id="25" name="TextBox 24"/>
           <p:cNvSpPr txBox="1"/>
           <p:nvPr/>
         </p:nvSpPr>
         <p:spPr>
           <a:xfrm>
-            <a:off x="731520" y="5394960"/>
-            <a:ext cx="10058400" cy="640080"/>
+            <a:off x="731520" y="5303520"/>
+            <a:ext cx="10058400" cy="548640"/>
           </a:xfrm>
           <a:prstGeom prst="rect">
             <a:avLst/>
@@ -8022,7 +7915,7 @@
     <p:bg>
       <p:bgPr>
         <a:solidFill>
-          <a:srgbClr val="05142B"/>
+          <a:srgbClr val="F8FAFC"/>
         </a:solidFill>
         <a:effectLst/>
       </p:bgPr>
@@ -8036,7 +7929,7 @@
       <p:grpSpPr/>
       <p:pic>
         <p:nvPicPr>
-          <p:cNvPr id="2" name="Picture 1" descr="snowflake_logo_white.png"/>
+          <p:cNvPr id="2" name="Picture 1" descr="sf_logo_combined.png"/>
           <p:cNvPicPr>
             <a:picLocks noChangeAspect="1"/>
           </p:cNvPicPr>
@@ -8050,8 +7943,8 @@
         </p:blipFill>
         <p:spPr>
           <a:xfrm>
-            <a:off x="457200" y="274320"/>
-            <a:ext cx="457200" cy="457200"/>
+            <a:off x="365760" y="228600"/>
+            <a:ext cx="2468880" cy="411480"/>
           </a:xfrm>
           <a:prstGeom prst="rect">
             <a:avLst/>
@@ -8066,8 +7959,8 @@
         </p:nvSpPr>
         <p:spPr>
           <a:xfrm>
-            <a:off x="457200" y="6446520"/>
-            <a:ext cx="11247120" cy="27432"/>
+            <a:off x="0" y="6583680"/>
+            <a:ext cx="12191695" cy="36576"/>
           </a:xfrm>
           <a:prstGeom prst="rect">
             <a:avLst/>
@@ -8109,8 +8002,8 @@
         </p:nvSpPr>
         <p:spPr>
           <a:xfrm>
-            <a:off x="731520" y="640080"/>
-            <a:ext cx="1645920" cy="548640"/>
+            <a:off x="731520" y="777240"/>
+            <a:ext cx="1463040" cy="457200"/>
           </a:xfrm>
           <a:prstGeom prst="roundRect">
             <a:avLst/>
@@ -8141,7 +8034,7 @@
           <a:lstStyle/>
           <a:p>
             <a:pPr algn="ctr">
-              <a:defRPr sz="1600" b="1">
+              <a:defRPr sz="1300" b="1">
                 <a:solidFill>
                   <a:srgbClr val="FFFFFF"/>
                 </a:solidFill>
@@ -8161,8 +8054,8 @@
         </p:nvSpPr>
         <p:spPr>
           <a:xfrm>
-            <a:off x="2560320" y="640080"/>
-            <a:ext cx="8229600" cy="548640"/>
+            <a:off x="2377440" y="777240"/>
+            <a:ext cx="8229600" cy="457200"/>
           </a:xfrm>
           <a:prstGeom prst="rect">
             <a:avLst/>
@@ -8176,51 +8069,27 @@
           <a:lstStyle/>
           <a:p>
             <a:pPr algn="l">
-              <a:defRPr sz="2400" b="1">
-                <a:solidFill>
-                  <a:srgbClr val="FFFFFF"/>
-                </a:solidFill>
-              </a:defRPr>
-            </a:pPr>
-            <a:r>
-              <a:t>Operate the Business</a:t>
-            </a:r>
-          </a:p>
-        </p:txBody>
-      </p:sp>
-      <p:pic>
-        <p:nvPicPr>
-          <p:cNvPr id="6" name="Picture 5" descr="icon_agent.png"/>
-          <p:cNvPicPr>
-            <a:picLocks noChangeAspect="1"/>
-          </p:cNvPicPr>
-          <p:nvPr/>
-        </p:nvPicPr>
-        <p:blipFill>
-          <a:blip r:embed="rId3"/>
-          <a:stretch>
-            <a:fillRect/>
-          </a:stretch>
-        </p:blipFill>
-        <p:spPr>
-          <a:xfrm>
-            <a:off x="10515600" y="548640"/>
-            <a:ext cx="731520" cy="731520"/>
-          </a:xfrm>
-          <a:prstGeom prst="rect">
-            <a:avLst/>
-          </a:prstGeom>
-        </p:spPr>
-      </p:pic>
-      <p:sp>
-        <p:nvSpPr>
-          <p:cNvPr id="7" name="TextBox 6"/>
+              <a:defRPr sz="2200" b="1">
+                <a:solidFill>
+                  <a:srgbClr val="11273F"/>
+                </a:solidFill>
+              </a:defRPr>
+            </a:pPr>
+            <a:r>
+              <a:t>Operate the Business — Action Plan</a:t>
+            </a:r>
+          </a:p>
+        </p:txBody>
+      </p:sp>
+      <p:sp>
+        <p:nvSpPr>
+          <p:cNvPr id="6" name="TextBox 5"/>
           <p:cNvSpPr txBox="1"/>
           <p:nvPr/>
         </p:nvSpPr>
         <p:spPr>
           <a:xfrm>
-            <a:off x="731520" y="1280160"/>
+            <a:off x="731520" y="1371600"/>
             <a:ext cx="10058400" cy="365760"/>
           </a:xfrm>
           <a:prstGeom prst="rect">
@@ -8235,9 +8104,9 @@
           <a:lstStyle/>
           <a:p>
             <a:pPr algn="l">
-              <a:defRPr sz="1600" b="1">
-                <a:solidFill>
-                  <a:srgbClr val="FFFFFF"/>
+              <a:defRPr sz="1500" b="1">
+                <a:solidFill>
+                  <a:srgbClr val="333333"/>
                 </a:solidFill>
               </a:defRPr>
             </a:pPr>
@@ -8249,25 +8118,23 @@
       </p:sp>
       <p:sp>
         <p:nvSpPr>
-          <p:cNvPr id="8" name="Rounded Rectangle 7"/>
+          <p:cNvPr id="7" name="Rounded Rectangle 6"/>
           <p:cNvSpPr/>
           <p:nvPr/>
         </p:nvSpPr>
         <p:spPr>
           <a:xfrm>
-            <a:off x="548640" y="1828800"/>
+            <a:off x="548640" y="1920240"/>
             <a:ext cx="2651760" cy="2011680"/>
           </a:xfrm>
           <a:prstGeom prst="roundRect">
             <a:avLst/>
           </a:prstGeom>
           <a:solidFill>
-            <a:srgbClr val="0A1E38"/>
+            <a:srgbClr val="2E7D32"/>
           </a:solidFill>
-          <a:ln w="25400">
-            <a:solidFill>
-              <a:srgbClr val="2E7D32"/>
-            </a:solidFill>
+          <a:ln>
+            <a:noFill/>
           </a:ln>
         </p:spPr>
         <p:style>
@@ -8294,13 +8161,13 @@
       </p:sp>
       <p:sp>
         <p:nvSpPr>
-          <p:cNvPr id="9" name="TextBox 8"/>
+          <p:cNvPr id="8" name="TextBox 7"/>
           <p:cNvSpPr txBox="1"/>
           <p:nvPr/>
         </p:nvSpPr>
         <p:spPr>
           <a:xfrm>
-            <a:off x="731520" y="1920240"/>
+            <a:off x="731520" y="2011680"/>
             <a:ext cx="2286000" cy="365760"/>
           </a:xfrm>
           <a:prstGeom prst="rect">
@@ -8315,9 +8182,9 @@
           <a:lstStyle/>
           <a:p>
             <a:pPr algn="l">
-              <a:defRPr sz="1300" b="1">
-                <a:solidFill>
-                  <a:srgbClr val="2E7D32"/>
+              <a:defRPr sz="1200" b="1">
+                <a:solidFill>
+                  <a:srgbClr val="FFFFFF"/>
                 </a:solidFill>
               </a:defRPr>
             </a:pPr>
@@ -8329,14 +8196,14 @@
       </p:sp>
       <p:sp>
         <p:nvSpPr>
-          <p:cNvPr id="10" name="TextBox 9"/>
+          <p:cNvPr id="9" name="TextBox 8"/>
           <p:cNvSpPr txBox="1"/>
           <p:nvPr/>
         </p:nvSpPr>
         <p:spPr>
           <a:xfrm>
-            <a:off x="731520" y="2377440"/>
-            <a:ext cx="2286000" cy="1371600"/>
+            <a:off x="731520" y="2468880"/>
+            <a:ext cx="2286000" cy="1280160"/>
           </a:xfrm>
           <a:prstGeom prst="rect">
             <a:avLst/>
@@ -8350,43 +8217,41 @@
           <a:lstStyle/>
           <a:p>
             <a:pPr algn="l">
-              <a:defRPr sz="1200" b="0">
+              <a:defRPr sz="1100" b="0">
                 <a:solidFill>
                   <a:srgbClr val="FFFFFF"/>
                 </a:solidFill>
               </a:defRPr>
             </a:pPr>
             <a:r>
-              <a:t>ABC Glass</a:t>
+              <a:t>ABC Glass — expedite</a:t>
             </a:r>
             <a:br/>
             <a:r>
-              <a:t>in-transit</a:t>
-            </a:r>
-          </a:p>
-        </p:txBody>
-      </p:sp>
-      <p:sp>
-        <p:nvSpPr>
-          <p:cNvPr id="11" name="Rounded Rectangle 10"/>
+              <a:t>in-transit shipments</a:t>
+            </a:r>
+          </a:p>
+        </p:txBody>
+      </p:sp>
+      <p:sp>
+        <p:nvSpPr>
+          <p:cNvPr id="10" name="Rounded Rectangle 9"/>
           <p:cNvSpPr/>
           <p:nvPr/>
         </p:nvSpPr>
         <p:spPr>
           <a:xfrm>
-            <a:off x="3429000" y="1828800"/>
+            <a:off x="3429000" y="1920240"/>
             <a:ext cx="2651760" cy="2011680"/>
           </a:xfrm>
           <a:prstGeom prst="roundRect">
             <a:avLst/>
           </a:prstGeom>
           <a:solidFill>
-            <a:srgbClr val="0A1E38"/>
+            <a:srgbClr val="29B5E8"/>
           </a:solidFill>
-          <a:ln w="25400">
-            <a:solidFill>
-              <a:srgbClr val="29B5E8"/>
-            </a:solidFill>
+          <a:ln>
+            <a:noFill/>
           </a:ln>
         </p:spPr>
         <p:style>
@@ -8413,13 +8278,13 @@
       </p:sp>
       <p:sp>
         <p:nvSpPr>
-          <p:cNvPr id="12" name="TextBox 11"/>
+          <p:cNvPr id="11" name="TextBox 10"/>
           <p:cNvSpPr txBox="1"/>
           <p:nvPr/>
         </p:nvSpPr>
         <p:spPr>
           <a:xfrm>
-            <a:off x="3611880" y="1920240"/>
+            <a:off x="3611880" y="2011680"/>
             <a:ext cx="2286000" cy="365760"/>
           </a:xfrm>
           <a:prstGeom prst="rect">
@@ -8434,9 +8299,9 @@
           <a:lstStyle/>
           <a:p>
             <a:pPr algn="l">
-              <a:defRPr sz="1300" b="1">
-                <a:solidFill>
-                  <a:srgbClr val="29B5E8"/>
+              <a:defRPr sz="1200" b="1">
+                <a:solidFill>
+                  <a:srgbClr val="FFFFFF"/>
                 </a:solidFill>
               </a:defRPr>
             </a:pPr>
@@ -8448,14 +8313,14 @@
       </p:sp>
       <p:sp>
         <p:nvSpPr>
-          <p:cNvPr id="13" name="TextBox 12"/>
+          <p:cNvPr id="12" name="TextBox 11"/>
           <p:cNvSpPr txBox="1"/>
           <p:nvPr/>
         </p:nvSpPr>
         <p:spPr>
           <a:xfrm>
-            <a:off x="3611880" y="2377440"/>
-            <a:ext cx="2286000" cy="1371600"/>
+            <a:off x="3611880" y="2468880"/>
+            <a:ext cx="2286000" cy="1280160"/>
           </a:xfrm>
           <a:prstGeom prst="rect">
             <a:avLst/>
@@ -8469,7 +8334,7 @@
           <a:lstStyle/>
           <a:p>
             <a:pPr algn="l">
-              <a:defRPr sz="1200" b="0">
+              <a:defRPr sz="1100" b="0">
                 <a:solidFill>
                   <a:srgbClr val="FFFFFF"/>
                 </a:solidFill>
@@ -8480,32 +8345,30 @@
             </a:r>
             <a:br/>
             <a:r>
-              <a:t>45d surplus, 2d</a:t>
-            </a:r>
-          </a:p>
-        </p:txBody>
-      </p:sp>
-      <p:sp>
-        <p:nvSpPr>
-          <p:cNvPr id="14" name="Rounded Rectangle 13"/>
+              <a:t>45d surplus, 2-day transit</a:t>
+            </a:r>
+          </a:p>
+        </p:txBody>
+      </p:sp>
+      <p:sp>
+        <p:nvSpPr>
+          <p:cNvPr id="13" name="Rounded Rectangle 12"/>
           <p:cNvSpPr/>
           <p:nvPr/>
         </p:nvSpPr>
         <p:spPr>
           <a:xfrm>
-            <a:off x="6309359" y="1828800"/>
+            <a:off x="6309359" y="1920240"/>
             <a:ext cx="2651760" cy="2011680"/>
           </a:xfrm>
           <a:prstGeom prst="roundRect">
             <a:avLst/>
           </a:prstGeom>
           <a:solidFill>
-            <a:srgbClr val="0A1E38"/>
+            <a:srgbClr val="E65100"/>
           </a:solidFill>
-          <a:ln w="25400">
-            <a:solidFill>
-              <a:srgbClr val="E65100"/>
-            </a:solidFill>
+          <a:ln>
+            <a:noFill/>
           </a:ln>
         </p:spPr>
         <p:style>
@@ -8532,13 +8395,13 @@
       </p:sp>
       <p:sp>
         <p:nvSpPr>
-          <p:cNvPr id="15" name="TextBox 14"/>
+          <p:cNvPr id="14" name="TextBox 13"/>
           <p:cNvSpPr txBox="1"/>
           <p:nvPr/>
         </p:nvSpPr>
         <p:spPr>
           <a:xfrm>
-            <a:off x="6492240" y="1920240"/>
+            <a:off x="6492240" y="2011680"/>
             <a:ext cx="2286000" cy="365760"/>
           </a:xfrm>
           <a:prstGeom prst="rect">
@@ -8553,9 +8416,9 @@
           <a:lstStyle/>
           <a:p>
             <a:pPr algn="l">
-              <a:defRPr sz="1300" b="1">
-                <a:solidFill>
-                  <a:srgbClr val="E65100"/>
+              <a:defRPr sz="1200" b="1">
+                <a:solidFill>
+                  <a:srgbClr val="FFFFFF"/>
                 </a:solidFill>
               </a:defRPr>
             </a:pPr>
@@ -8567,14 +8430,14 @@
       </p:sp>
       <p:sp>
         <p:nvSpPr>
-          <p:cNvPr id="16" name="TextBox 15"/>
+          <p:cNvPr id="15" name="TextBox 14"/>
           <p:cNvSpPr txBox="1"/>
           <p:nvPr/>
         </p:nvSpPr>
         <p:spPr>
           <a:xfrm>
-            <a:off x="6492240" y="2377440"/>
-            <a:ext cx="2286000" cy="1371600"/>
+            <a:off x="6492240" y="2468880"/>
+            <a:ext cx="2286000" cy="1280160"/>
           </a:xfrm>
           <a:prstGeom prst="rect">
             <a:avLst/>
@@ -8588,43 +8451,41 @@
           <a:lstStyle/>
           <a:p>
             <a:pPr algn="l">
-              <a:defRPr sz="1200" b="0">
+              <a:defRPr sz="1100" b="0">
                 <a:solidFill>
                   <a:srgbClr val="FFFFFF"/>
                 </a:solidFill>
               </a:defRPr>
             </a:pPr>
             <a:r>
-              <a:t>Guardian Glass</a:t>
+              <a:t>Guardian Glass (MI)</a:t>
             </a:r>
             <a:br/>
             <a:r>
-              <a:t>Emergency</a:t>
-            </a:r>
-          </a:p>
-        </p:txBody>
-      </p:sp>
-      <p:sp>
-        <p:nvSpPr>
-          <p:cNvPr id="17" name="Rounded Rectangle 16"/>
+              <a:t>emergency supply</a:t>
+            </a:r>
+          </a:p>
+        </p:txBody>
+      </p:sp>
+      <p:sp>
+        <p:nvSpPr>
+          <p:cNvPr id="16" name="Rounded Rectangle 15"/>
           <p:cNvSpPr/>
           <p:nvPr/>
         </p:nvSpPr>
         <p:spPr>
           <a:xfrm>
-            <a:off x="9189719" y="1828800"/>
+            <a:off x="9189719" y="1920240"/>
             <a:ext cx="2651760" cy="2011680"/>
           </a:xfrm>
           <a:prstGeom prst="roundRect">
             <a:avLst/>
           </a:prstGeom>
           <a:solidFill>
-            <a:srgbClr val="0A1E38"/>
+            <a:srgbClr val="6A1B9A"/>
           </a:solidFill>
-          <a:ln w="25400">
-            <a:solidFill>
-              <a:srgbClr val="6A1B9A"/>
-            </a:solidFill>
+          <a:ln>
+            <a:noFill/>
           </a:ln>
         </p:spPr>
         <p:style>
@@ -8651,13 +8512,13 @@
       </p:sp>
       <p:sp>
         <p:nvSpPr>
-          <p:cNvPr id="18" name="TextBox 17"/>
+          <p:cNvPr id="17" name="TextBox 16"/>
           <p:cNvSpPr txBox="1"/>
           <p:nvPr/>
         </p:nvSpPr>
         <p:spPr>
           <a:xfrm>
-            <a:off x="9372600" y="1920240"/>
+            <a:off x="9372600" y="2011680"/>
             <a:ext cx="2286000" cy="365760"/>
           </a:xfrm>
           <a:prstGeom prst="rect">
@@ -8672,9 +8533,9 @@
           <a:lstStyle/>
           <a:p>
             <a:pPr algn="l">
-              <a:defRPr sz="1300" b="1">
-                <a:solidFill>
-                  <a:srgbClr val="6A1B9A"/>
+              <a:defRPr sz="1200" b="1">
+                <a:solidFill>
+                  <a:srgbClr val="FFFFFF"/>
                 </a:solidFill>
               </a:defRPr>
             </a:pPr>
@@ -8686,14 +8547,14 @@
       </p:sp>
       <p:sp>
         <p:nvSpPr>
-          <p:cNvPr id="19" name="TextBox 18"/>
+          <p:cNvPr id="18" name="TextBox 17"/>
           <p:cNvSpPr txBox="1"/>
           <p:nvPr/>
         </p:nvSpPr>
         <p:spPr>
           <a:xfrm>
-            <a:off x="9372600" y="2377440"/>
-            <a:ext cx="2286000" cy="1371600"/>
+            <a:off x="9372600" y="2468880"/>
+            <a:ext cx="2286000" cy="1280160"/>
           </a:xfrm>
           <a:prstGeom prst="rect">
             <a:avLst/>
@@ -8707,43 +8568,41 @@
           <a:lstStyle/>
           <a:p>
             <a:pPr algn="l">
-              <a:defRPr sz="1200" b="0">
+              <a:defRPr sz="1100" b="0">
                 <a:solidFill>
                   <a:srgbClr val="FFFFFF"/>
                 </a:solidFill>
               </a:defRPr>
             </a:pPr>
             <a:r>
-              <a:t>NextEra Q2</a:t>
+              <a:t>NextEra Q2, Invenergy</a:t>
             </a:r>
             <a:br/>
             <a:r>
-              <a:t>Invenergy</a:t>
-            </a:r>
-          </a:p>
-        </p:txBody>
-      </p:sp>
-      <p:sp>
-        <p:nvSpPr>
-          <p:cNvPr id="20" name="Rounded Rectangle 19"/>
+              <a:t>Magnolia commitments</a:t>
+            </a:r>
+          </a:p>
+        </p:txBody>
+      </p:sp>
+      <p:sp>
+        <p:nvSpPr>
+          <p:cNvPr id="19" name="Rounded Rectangle 18"/>
           <p:cNvSpPr/>
           <p:nvPr/>
         </p:nvSpPr>
         <p:spPr>
           <a:xfrm>
-            <a:off x="731520" y="4206240"/>
-            <a:ext cx="10515600" cy="914400"/>
+            <a:off x="731520" y="4297680"/>
+            <a:ext cx="10515600" cy="822960"/>
           </a:xfrm>
           <a:prstGeom prst="roundRect">
             <a:avLst/>
           </a:prstGeom>
           <a:solidFill>
-            <a:srgbClr val="0A1E38"/>
+            <a:srgbClr val="11273F"/>
           </a:solidFill>
-          <a:ln w="25400">
-            <a:solidFill>
-              <a:srgbClr val="29B5E8"/>
-            </a:solidFill>
+          <a:ln>
+            <a:noFill/>
           </a:ln>
         </p:spPr>
         <p:style>
@@ -8770,14 +8629,14 @@
       </p:sp>
       <p:sp>
         <p:nvSpPr>
-          <p:cNvPr id="21" name="TextBox 20"/>
+          <p:cNvPr id="20" name="TextBox 19"/>
           <p:cNvSpPr txBox="1"/>
           <p:nvPr/>
         </p:nvSpPr>
         <p:spPr>
           <a:xfrm>
-            <a:off x="1188720" y="4297680"/>
-            <a:ext cx="9601200" cy="822960"/>
+            <a:off x="1188720" y="4389120"/>
+            <a:ext cx="9601200" cy="640080"/>
           </a:xfrm>
           <a:prstGeom prst="rect">
             <a:avLst/>
@@ -8791,7 +8650,7 @@
           <a:lstStyle/>
           <a:p>
             <a:pPr algn="l">
-              <a:defRPr sz="1400" b="1">
+              <a:defRPr sz="1300" b="1">
                 <a:solidFill>
                   <a:srgbClr val="29B5E8"/>
                 </a:solidFill>
@@ -8805,7 +8664,7 @@
       </p:sp>
       <p:sp>
         <p:nvSpPr>
-          <p:cNvPr id="22" name="TextBox 21"/>
+          <p:cNvPr id="21" name="TextBox 20"/>
           <p:cNvSpPr txBox="1"/>
           <p:nvPr/>
         </p:nvSpPr>
@@ -8852,7 +8711,7 @@
     <p:bg>
       <p:bgPr>
         <a:solidFill>
-          <a:srgbClr val="05142B"/>
+          <a:srgbClr val="F8FAFC"/>
         </a:solidFill>
         <a:effectLst/>
       </p:bgPr>
@@ -8866,7 +8725,7 @@
       <p:grpSpPr/>
       <p:pic>
         <p:nvPicPr>
-          <p:cNvPr id="2" name="Picture 1" descr="snowflake_logo_white.png"/>
+          <p:cNvPr id="2" name="Picture 1" descr="sf_logo_combined.png"/>
           <p:cNvPicPr>
             <a:picLocks noChangeAspect="1"/>
           </p:cNvPicPr>
@@ -8880,8 +8739,8 @@
         </p:blipFill>
         <p:spPr>
           <a:xfrm>
-            <a:off x="457200" y="274320"/>
-            <a:ext cx="457200" cy="457200"/>
+            <a:off x="365760" y="228600"/>
+            <a:ext cx="2468880" cy="411480"/>
           </a:xfrm>
           <a:prstGeom prst="rect">
             <a:avLst/>
@@ -8896,8 +8755,8 @@
         </p:nvSpPr>
         <p:spPr>
           <a:xfrm>
-            <a:off x="457200" y="6446520"/>
-            <a:ext cx="11247120" cy="27432"/>
+            <a:off x="0" y="6583680"/>
+            <a:ext cx="12191695" cy="36576"/>
           </a:xfrm>
           <a:prstGeom prst="rect">
             <a:avLst/>
@@ -8939,7 +8798,7 @@
         </p:nvSpPr>
         <p:spPr>
           <a:xfrm>
-            <a:off x="731520" y="731520"/>
+            <a:off x="731520" y="777240"/>
             <a:ext cx="10058400" cy="548640"/>
           </a:xfrm>
           <a:prstGeom prst="rect">
@@ -8954,14 +8813,14 @@
           <a:lstStyle/>
           <a:p>
             <a:pPr algn="l">
-              <a:defRPr sz="3200" b="1">
-                <a:solidFill>
-                  <a:srgbClr val="29B5E8"/>
-                </a:solidFill>
-              </a:defRPr>
-            </a:pPr>
-            <a:r>
-              <a:t>Impact — Land It in MW</a:t>
+              <a:defRPr sz="3000" b="1">
+                <a:solidFill>
+                  <a:srgbClr val="11273F"/>
+                </a:solidFill>
+              </a:defRPr>
+            </a:pPr>
+            <a:r>
+              <a:t>Impact — Land It in Their Units</a:t>
             </a:r>
           </a:p>
         </p:txBody>
@@ -8975,18 +8834,16 @@
         <p:spPr>
           <a:xfrm>
             <a:off x="731520" y="1554480"/>
-            <a:ext cx="5029200" cy="3200400"/>
+            <a:ext cx="5029200" cy="3474720"/>
           </a:xfrm>
           <a:prstGeom prst="roundRect">
             <a:avLst/>
           </a:prstGeom>
           <a:solidFill>
-            <a:srgbClr val="0A1E38"/>
+            <a:srgbClr val="11273F"/>
           </a:solidFill>
-          <a:ln w="25400">
-            <a:solidFill>
-              <a:srgbClr val="C62828"/>
-            </a:solidFill>
+          <a:ln>
+            <a:noFill/>
           </a:ln>
         </p:spPr>
         <p:style>
@@ -9034,9 +8891,9 @@
           <a:lstStyle/>
           <a:p>
             <a:pPr algn="ctr">
-              <a:defRPr sz="1300" b="0">
-                <a:solidFill>
-                  <a:srgbClr val="8E9EAB"/>
+              <a:defRPr sz="1200" b="0">
+                <a:solidFill>
+                  <a:srgbClr val="6B7B8D"/>
                 </a:solidFill>
               </a:defRPr>
             </a:pPr>
@@ -9089,7 +8946,7 @@
         </p:nvSpPr>
         <p:spPr>
           <a:xfrm>
-            <a:off x="1188720" y="3291840"/>
+            <a:off x="1188720" y="3383280"/>
             <a:ext cx="4114800" cy="457200"/>
           </a:xfrm>
           <a:prstGeom prst="rect">
@@ -9104,14 +8961,14 @@
           <a:lstStyle/>
           <a:p>
             <a:pPr algn="ctr">
-              <a:defRPr sz="1800" b="1">
+              <a:defRPr sz="1700" b="1">
                 <a:solidFill>
                   <a:srgbClr val="FFFFFF"/>
                 </a:solidFill>
               </a:defRPr>
             </a:pPr>
             <a:r>
-              <a:t>~$40M Revenue</a:t>
+              <a:t>~$40M Revenue Exposure</a:t>
             </a:r>
           </a:p>
         </p:txBody>
@@ -9124,8 +8981,8 @@
         </p:nvSpPr>
         <p:spPr>
           <a:xfrm>
-            <a:off x="1188720" y="3840480"/>
-            <a:ext cx="4114800" cy="548640"/>
+            <a:off x="1188720" y="4023360"/>
+            <a:ext cx="4114800" cy="457200"/>
           </a:xfrm>
           <a:prstGeom prst="rect">
             <a:avLst/>
@@ -9139,14 +8996,14 @@
           <a:lstStyle/>
           <a:p>
             <a:pPr algn="ctr">
-              <a:defRPr sz="1200" b="0">
-                <a:solidFill>
-                  <a:srgbClr val="8E9EAB"/>
-                </a:solidFill>
-              </a:defRPr>
-            </a:pPr>
-            <a:r>
-              <a:t>14d × 9.6 MW/day</a:t>
+              <a:defRPr sz="1100" b="0">
+                <a:solidFill>
+                  <a:srgbClr val="6B7B8D"/>
+                </a:solidFill>
+              </a:defRPr>
+            </a:pPr>
+            <a:r>
+              <a:t>14d × 9.6 MW/day @ $0.30/W</a:t>
             </a:r>
           </a:p>
         </p:txBody>
@@ -9160,7 +9017,7 @@
         <p:spPr>
           <a:xfrm>
             <a:off x="6400800" y="1645920"/>
-            <a:ext cx="5029200" cy="3200400"/>
+            <a:ext cx="5029200" cy="3474720"/>
           </a:xfrm>
           <a:prstGeom prst="rect">
             <a:avLst/>
@@ -9176,12 +9033,12 @@
             <a:pPr algn="l">
               <a:defRPr sz="1300" b="0">
                 <a:solidFill>
-                  <a:srgbClr val="FFFFFF"/>
-                </a:solidFill>
-              </a:defRPr>
-            </a:pPr>
-            <a:r>
-              <a:t>Alabama: 9.6 MW/day</a:t>
+                  <a:srgbClr val="333333"/>
+                </a:solidFill>
+              </a:defRPr>
+            </a:pPr>
+            <a:r>
+              <a:t>Alabama: 3,500 MW ÷ 365 = 9.6 MW/day</a:t>
             </a:r>
             <a:br/>
             <a:br/>
@@ -9191,7 +9048,7 @@
             <a:br/>
             <a:br/>
             <a:r>
-              <a:t>2-week delay:</a:t>
+              <a:t>2-week delay beyond coverage:</a:t>
             </a:r>
             <a:br/>
             <a:r>
@@ -9200,24 +9057,24 @@
             <a:br/>
             <a:br/>
             <a:r>
-              <a:t>At $0.30/W:</a:t>
+              <a:t>At $0.30/W ASP:</a:t>
             </a:r>
             <a:br/>
             <a:r>
-              <a:t>  134 MW = ~$40M</a:t>
+              <a:t>  134 MW × $300K = ~$40M</a:t>
             </a:r>
             <a:br/>
             <a:br/>
             <a:r>
-              <a:t>Customers at risk:</a:t>
+              <a:t>Customers:</a:t>
             </a:r>
             <a:br/>
             <a:r>
-              <a:t>  NextEra Q2</a:t>
+              <a:t>  NextEra Q2 commissioning</a:t>
             </a:r>
             <a:br/>
             <a:r>
-              <a:t>  Invenergy Magnolia</a:t>
+              <a:t>  Invenergy Magnolia Solar</a:t>
             </a:r>
           </a:p>
         </p:txBody>
@@ -9230,8 +9087,8 @@
         </p:nvSpPr>
         <p:spPr>
           <a:xfrm>
-            <a:off x="731520" y="5029200"/>
-            <a:ext cx="10058400" cy="457200"/>
+            <a:off x="731520" y="5303520"/>
+            <a:ext cx="10058400" cy="365760"/>
           </a:xfrm>
           <a:prstGeom prst="rect">
             <a:avLst/>
@@ -9245,14 +9102,14 @@
           <a:lstStyle/>
           <a:p>
             <a:pPr algn="l">
-              <a:defRPr sz="1200" b="1">
+              <a:defRPr sz="1100" b="1">
                 <a:solidFill>
                   <a:srgbClr val="E65100"/>
                 </a:solidFill>
               </a:defRPr>
             </a:pPr>
             <a:r>
-              <a:t>ALWAYS quantify in MW and $. That makes them lean in.</a:t>
+              <a:t>ALWAYS land in MW and $. That makes the CSCO lean in.</a:t>
             </a:r>
           </a:p>
         </p:txBody>
@@ -9271,7 +9128,7 @@
     <p:bg>
       <p:bgPr>
         <a:solidFill>
-          <a:srgbClr val="05142B"/>
+          <a:srgbClr val="F8FAFC"/>
         </a:solidFill>
         <a:effectLst/>
       </p:bgPr>
@@ -9285,7 +9142,7 @@
       <p:grpSpPr/>
       <p:pic>
         <p:nvPicPr>
-          <p:cNvPr id="2" name="Picture 1" descr="snowflake_logo_white.png"/>
+          <p:cNvPr id="2" name="Picture 1" descr="sf_logo_combined.png"/>
           <p:cNvPicPr>
             <a:picLocks noChangeAspect="1"/>
           </p:cNvPicPr>
@@ -9299,8 +9156,8 @@
         </p:blipFill>
         <p:spPr>
           <a:xfrm>
-            <a:off x="457200" y="274320"/>
-            <a:ext cx="457200" cy="457200"/>
+            <a:off x="365760" y="228600"/>
+            <a:ext cx="2468880" cy="411480"/>
           </a:xfrm>
           <a:prstGeom prst="rect">
             <a:avLst/>
@@ -9315,8 +9172,8 @@
         </p:nvSpPr>
         <p:spPr>
           <a:xfrm>
-            <a:off x="457200" y="6446520"/>
-            <a:ext cx="11247120" cy="27432"/>
+            <a:off x="0" y="6583680"/>
+            <a:ext cx="12191695" cy="36576"/>
           </a:xfrm>
           <a:prstGeom prst="rect">
             <a:avLst/>
@@ -9358,7 +9215,7 @@
         </p:nvSpPr>
         <p:spPr>
           <a:xfrm>
-            <a:off x="731520" y="731520"/>
+            <a:off x="731520" y="777240"/>
             <a:ext cx="10058400" cy="548640"/>
           </a:xfrm>
           <a:prstGeom prst="rect">
@@ -9373,14 +9230,14 @@
           <a:lstStyle/>
           <a:p>
             <a:pPr algn="l">
-              <a:defRPr sz="3200" b="1">
-                <a:solidFill>
-                  <a:srgbClr val="29B5E8"/>
-                </a:solidFill>
-              </a:defRPr>
-            </a:pPr>
-            <a:r>
-              <a:t>Architecture — 11 Tools</a:t>
+              <a:defRPr sz="3000" b="1">
+                <a:solidFill>
+                  <a:srgbClr val="11273F"/>
+                </a:solidFill>
+              </a:defRPr>
+            </a:pPr>
+            <a:r>
+              <a:t>Agent Architecture — 11 Tools</a:t>
             </a:r>
           </a:p>
         </p:txBody>
@@ -9394,7 +9251,7 @@
         <p:spPr>
           <a:xfrm>
             <a:off x="731520" y="1371600"/>
-            <a:ext cx="10515600" cy="640080"/>
+            <a:ext cx="10515600" cy="548640"/>
           </a:xfrm>
           <a:prstGeom prst="roundRect">
             <a:avLst/>
@@ -9425,14 +9282,14 @@
           <a:lstStyle/>
           <a:p>
             <a:pPr algn="ctr">
-              <a:defRPr sz="1200" b="1">
+              <a:defRPr sz="1100" b="1">
                 <a:solidFill>
                   <a:srgbClr val="FFFFFF"/>
                 </a:solidFill>
               </a:defRPr>
             </a:pPr>
             <a:r>
-              <a:t>FIRST_SOLAR_AGENT | YAML | 15 Questions | 60s/32K</a:t>
+              <a:t>FIRST_SOLAR_AGENT  |  YAML  |  15 Sample Questions  |  60s / 32K tokens</a:t>
             </a:r>
           </a:p>
         </p:txBody>
@@ -9445,7 +9302,7 @@
         </p:nvSpPr>
         <p:spPr>
           <a:xfrm>
-            <a:off x="731520" y="2194560"/>
+            <a:off x="731520" y="2103120"/>
             <a:ext cx="3474720" cy="365760"/>
           </a:xfrm>
           <a:prstGeom prst="rect">
@@ -9460,7 +9317,7 @@
           <a:lstStyle/>
           <a:p>
             <a:pPr algn="l">
-              <a:defRPr sz="1200" b="1">
+              <a:defRPr sz="1100" b="1">
                 <a:solidFill>
                   <a:srgbClr val="29B5E8"/>
                 </a:solidFill>
@@ -9480,19 +9337,17 @@
         </p:nvSpPr>
         <p:spPr>
           <a:xfrm>
-            <a:off x="731520" y="2651760"/>
-            <a:ext cx="3383280" cy="640080"/>
+            <a:off x="731520" y="2560320"/>
+            <a:ext cx="3383280" cy="594360"/>
           </a:xfrm>
           <a:prstGeom prst="roundRect">
             <a:avLst/>
           </a:prstGeom>
           <a:solidFill>
-            <a:srgbClr val="0A1E38"/>
+            <a:srgbClr val="29B5E8"/>
           </a:solidFill>
-          <a:ln w="25400">
-            <a:solidFill>
-              <a:srgbClr val="29B5E8"/>
-            </a:solidFill>
+          <a:ln>
+            <a:noFill/>
           </a:ln>
         </p:spPr>
         <p:style>
@@ -9534,19 +9389,17 @@
         </p:nvSpPr>
         <p:spPr>
           <a:xfrm>
-            <a:off x="731520" y="3429000"/>
-            <a:ext cx="3383280" cy="640080"/>
+            <a:off x="731520" y="3291839"/>
+            <a:ext cx="3383280" cy="594360"/>
           </a:xfrm>
           <a:prstGeom prst="roundRect">
             <a:avLst/>
           </a:prstGeom>
           <a:solidFill>
-            <a:srgbClr val="0A1E38"/>
+            <a:srgbClr val="29B5E8"/>
           </a:solidFill>
-          <a:ln w="25400">
-            <a:solidFill>
-              <a:srgbClr val="29B5E8"/>
-            </a:solidFill>
+          <a:ln>
+            <a:noFill/>
           </a:ln>
         </p:spPr>
         <p:style>
@@ -9588,19 +9441,17 @@
         </p:nvSpPr>
         <p:spPr>
           <a:xfrm>
-            <a:off x="731520" y="4206240"/>
-            <a:ext cx="3383280" cy="640080"/>
+            <a:off x="731520" y="4023360"/>
+            <a:ext cx="3383280" cy="594360"/>
           </a:xfrm>
           <a:prstGeom prst="roundRect">
             <a:avLst/>
           </a:prstGeom>
           <a:solidFill>
-            <a:srgbClr val="0A1E38"/>
+            <a:srgbClr val="29B5E8"/>
           </a:solidFill>
-          <a:ln w="25400">
-            <a:solidFill>
-              <a:srgbClr val="29B5E8"/>
-            </a:solidFill>
+          <a:ln>
+            <a:noFill/>
           </a:ln>
         </p:spPr>
         <p:style>
@@ -9642,7 +9493,7 @@
         </p:nvSpPr>
         <p:spPr>
           <a:xfrm>
-            <a:off x="4480559" y="2194560"/>
+            <a:off x="4480559" y="2103120"/>
             <a:ext cx="3474720" cy="365760"/>
           </a:xfrm>
           <a:prstGeom prst="rect">
@@ -9657,7 +9508,7 @@
           <a:lstStyle/>
           <a:p>
             <a:pPr algn="l">
-              <a:defRPr sz="1200" b="1">
+              <a:defRPr sz="1100" b="1">
                 <a:solidFill>
                   <a:srgbClr val="2E7D32"/>
                 </a:solidFill>
@@ -9677,19 +9528,17 @@
         </p:nvSpPr>
         <p:spPr>
           <a:xfrm>
-            <a:off x="4480559" y="2651760"/>
-            <a:ext cx="3383280" cy="640080"/>
+            <a:off x="4480559" y="2560320"/>
+            <a:ext cx="3383280" cy="594360"/>
           </a:xfrm>
           <a:prstGeom prst="roundRect">
             <a:avLst/>
           </a:prstGeom>
           <a:solidFill>
-            <a:srgbClr val="0A1E38"/>
+            <a:srgbClr val="2E7D32"/>
           </a:solidFill>
-          <a:ln w="25400">
-            <a:solidFill>
-              <a:srgbClr val="2E7D32"/>
-            </a:solidFill>
+          <a:ln>
+            <a:noFill/>
           </a:ln>
         </p:spPr>
         <p:style>
@@ -9731,19 +9580,17 @@
         </p:nvSpPr>
         <p:spPr>
           <a:xfrm>
-            <a:off x="4480559" y="3429000"/>
-            <a:ext cx="3383280" cy="640080"/>
+            <a:off x="4480559" y="3291839"/>
+            <a:ext cx="3383280" cy="594360"/>
           </a:xfrm>
           <a:prstGeom prst="roundRect">
             <a:avLst/>
           </a:prstGeom>
           <a:solidFill>
-            <a:srgbClr val="0A1E38"/>
+            <a:srgbClr val="2E7D32"/>
           </a:solidFill>
-          <a:ln w="25400">
-            <a:solidFill>
-              <a:srgbClr val="2E7D32"/>
-            </a:solidFill>
+          <a:ln>
+            <a:noFill/>
           </a:ln>
         </p:spPr>
         <p:style>
@@ -9785,19 +9632,17 @@
         </p:nvSpPr>
         <p:spPr>
           <a:xfrm>
-            <a:off x="4480559" y="4206240"/>
-            <a:ext cx="3383280" cy="640080"/>
+            <a:off x="4480559" y="4023360"/>
+            <a:ext cx="3383280" cy="594360"/>
           </a:xfrm>
           <a:prstGeom prst="roundRect">
             <a:avLst/>
           </a:prstGeom>
           <a:solidFill>
-            <a:srgbClr val="0A1E38"/>
+            <a:srgbClr val="2E7D32"/>
           </a:solidFill>
-          <a:ln w="25400">
-            <a:solidFill>
-              <a:srgbClr val="2E7D32"/>
-            </a:solidFill>
+          <a:ln>
+            <a:noFill/>
           </a:ln>
         </p:spPr>
         <p:style>
@@ -9839,19 +9684,17 @@
         </p:nvSpPr>
         <p:spPr>
           <a:xfrm>
-            <a:off x="4480559" y="4983479"/>
-            <a:ext cx="3383280" cy="640080"/>
+            <a:off x="4480559" y="4754880"/>
+            <a:ext cx="3383280" cy="594360"/>
           </a:xfrm>
           <a:prstGeom prst="roundRect">
             <a:avLst/>
           </a:prstGeom>
           <a:solidFill>
-            <a:srgbClr val="0A1E38"/>
+            <a:srgbClr val="2E7D32"/>
           </a:solidFill>
-          <a:ln w="25400">
-            <a:solidFill>
-              <a:srgbClr val="2E7D32"/>
-            </a:solidFill>
+          <a:ln>
+            <a:noFill/>
           </a:ln>
         </p:spPr>
         <p:style>
@@ -9893,7 +9736,7 @@
         </p:nvSpPr>
         <p:spPr>
           <a:xfrm>
-            <a:off x="8229600" y="2194560"/>
+            <a:off x="8229600" y="2103120"/>
             <a:ext cx="3474720" cy="365760"/>
           </a:xfrm>
           <a:prstGeom prst="rect">
@@ -9908,7 +9751,7 @@
           <a:lstStyle/>
           <a:p>
             <a:pPr algn="l">
-              <a:defRPr sz="1200" b="1">
+              <a:defRPr sz="1100" b="1">
                 <a:solidFill>
                   <a:srgbClr val="E65100"/>
                 </a:solidFill>
@@ -9928,19 +9771,17 @@
         </p:nvSpPr>
         <p:spPr>
           <a:xfrm>
-            <a:off x="8229600" y="2651760"/>
-            <a:ext cx="3383280" cy="640080"/>
+            <a:off x="8229600" y="2560320"/>
+            <a:ext cx="3383280" cy="594360"/>
           </a:xfrm>
           <a:prstGeom prst="roundRect">
             <a:avLst/>
           </a:prstGeom>
           <a:solidFill>
-            <a:srgbClr val="0A1E38"/>
+            <a:srgbClr val="E65100"/>
           </a:solidFill>
-          <a:ln w="25400">
-            <a:solidFill>
-              <a:srgbClr val="E65100"/>
-            </a:solidFill>
+          <a:ln>
+            <a:noFill/>
           </a:ln>
         </p:spPr>
         <p:style>
@@ -9982,19 +9823,17 @@
         </p:nvSpPr>
         <p:spPr>
           <a:xfrm>
-            <a:off x="8229600" y="3429000"/>
-            <a:ext cx="3383280" cy="640080"/>
+            <a:off x="8229600" y="3291839"/>
+            <a:ext cx="3383280" cy="594360"/>
           </a:xfrm>
           <a:prstGeom prst="roundRect">
             <a:avLst/>
           </a:prstGeom>
           <a:solidFill>
-            <a:srgbClr val="0A1E38"/>
+            <a:srgbClr val="E65100"/>
           </a:solidFill>
-          <a:ln w="25400">
-            <a:solidFill>
-              <a:srgbClr val="E65100"/>
-            </a:solidFill>
+          <a:ln>
+            <a:noFill/>
           </a:ln>
         </p:spPr>
         <p:style>
@@ -10036,19 +9875,17 @@
         </p:nvSpPr>
         <p:spPr>
           <a:xfrm>
-            <a:off x="8229600" y="4206240"/>
-            <a:ext cx="3383280" cy="640080"/>
+            <a:off x="8229600" y="4023360"/>
+            <a:ext cx="3383280" cy="594360"/>
           </a:xfrm>
           <a:prstGeom prst="roundRect">
             <a:avLst/>
           </a:prstGeom>
           <a:solidFill>
-            <a:srgbClr val="0A1E38"/>
+            <a:srgbClr val="E65100"/>
           </a:solidFill>
-          <a:ln w="25400">
-            <a:solidFill>
-              <a:srgbClr val="E65100"/>
-            </a:solidFill>
+          <a:ln>
+            <a:noFill/>
           </a:ln>
         </p:spPr>
         <p:style>
@@ -10090,19 +9927,17 @@
         </p:nvSpPr>
         <p:spPr>
           <a:xfrm>
-            <a:off x="8229600" y="4983479"/>
-            <a:ext cx="3383280" cy="640080"/>
+            <a:off x="8229600" y="4754880"/>
+            <a:ext cx="3383280" cy="594360"/>
           </a:xfrm>
           <a:prstGeom prst="roundRect">
             <a:avLst/>
           </a:prstGeom>
           <a:solidFill>
-            <a:srgbClr val="0A1E38"/>
+            <a:srgbClr val="E65100"/>
           </a:solidFill>
-          <a:ln w="25400">
-            <a:solidFill>
-              <a:srgbClr val="E65100"/>
-            </a:solidFill>
+          <a:ln>
+            <a:noFill/>
           </a:ln>
         </p:spPr>
         <p:style>

</xml_diff>